<commit_message>
Slides: scope reference counting to CPython in the sd-10-002 deck
Co-Authored-By: Claude Sonnet 5.5 <noreply@anthropic.com>
Claude-Session: https://claude.ai/code/session_01E4oCkXXqBf2c7oMUzFxEr2
</commit_message>
<xml_diff>
--- a/system-design-101/vi/lessons/sd-10-002/slides/sd-10-002.pptx
+++ b/system-design-101/vi/lessons/sd-10-002/slides/sd-10-002.pptx
@@ -2343,7 +2343,7 @@
         <p:spPr>
           <a:xfrm>
             <a:off x="5334000" y="8115300"/>
-            <a:ext cx="2095500" cy="323850"/>
+            <a:ext cx="2286000" cy="323850"/>
           </a:xfrm>
           <a:prstGeom prst="rect">
             <a:avLst/>
@@ -2378,18 +2378,7 @@
                 <a:ea typeface="Be Vietnam Pro" pitchFamily="34" charset="-122"/>
                 <a:cs typeface="Be Vietnam Pro" pitchFamily="34" charset="-120"/>
               </a:rPr>
-              <a:t> của</a:t>
-            </a:r>
-            <a:r>
-              <a:rPr lang="en-US" sz="1800" dirty="0" spc="4" kern="0">
-                <a:solidFill>
-                  <a:srgbClr val="9AA0B5"/>
-                </a:solidFill>
-                <a:latin typeface="Be Vietnam Pro" pitchFamily="34" charset="0"/>
-                <a:ea typeface="Be Vietnam Pro" pitchFamily="34" charset="-122"/>
-                <a:cs typeface="Be Vietnam Pro" pitchFamily="34" charset="-120"/>
-              </a:rPr>
-              <a:t> Python</a:t>
+              <a:t> của CPython</a:t>
             </a:r>
             <a:endParaRPr lang="en-US" sz="1800" dirty="0"/>
           </a:p>
@@ -2868,7 +2857,7 @@
               <a:buNone/>
             </a:pPr>
             <a:r>
-              <a:rPr lang="en-US" sz="3600" dirty="0" spc="4" kern="0">
+              <a:rPr lang="en-US" sz="3600" dirty="0" spc="3" kern="0">
                 <a:solidFill>
                   <a:srgbClr val="FFB454"/>
                 </a:solidFill>
@@ -2876,7 +2865,7 @@
                 <a:ea typeface="Bricolage Grotesque ExtraBold" pitchFamily="34" charset="-122"/>
                 <a:cs typeface="Bricolage Grotesque ExtraBold" pitchFamily="34" charset="-120"/>
               </a:rPr>
-              <a:t>Python</a:t>
+              <a:t>CPython</a:t>
             </a:r>
             <a:endParaRPr lang="en-US" sz="3600" dirty="0"/>
           </a:p>
@@ -5576,37 +5565,26 @@
               <a:t> Java,</a:t>
             </a:r>
             <a:r>
-              <a:rPr lang="en-US" sz="2700" dirty="0" spc="7" kern="0">
-                <a:solidFill>
-                  <a:srgbClr val="14161C"/>
-                </a:solidFill>
-                <a:latin typeface="Be Vietnam Pro" pitchFamily="34" charset="0"/>
-                <a:ea typeface="Be Vietnam Pro" pitchFamily="34" charset="-122"/>
-                <a:cs typeface="Be Vietnam Pro" pitchFamily="34" charset="-120"/>
-              </a:rPr>
-              <a:t> Python</a:t>
-            </a:r>
-            <a:r>
-              <a:rPr lang="en-US" sz="2700" dirty="0" spc="-18" kern="0">
-                <a:solidFill>
-                  <a:srgbClr val="14161C"/>
-                </a:solidFill>
-                <a:latin typeface="Be Vietnam Pro" pitchFamily="34" charset="0"/>
-                <a:ea typeface="Be Vietnam Pro" pitchFamily="34" charset="-122"/>
-                <a:cs typeface="Be Vietnam Pro" pitchFamily="34" charset="-120"/>
-              </a:rPr>
-              <a:t> và</a:t>
-            </a:r>
-            <a:r>
-              <a:rPr lang="en-US" sz="2700" dirty="0" spc="-3" kern="0">
-                <a:solidFill>
-                  <a:srgbClr val="14161C"/>
-                </a:solidFill>
-                <a:latin typeface="Be Vietnam Pro" pitchFamily="34" charset="0"/>
-                <a:ea typeface="Be Vietnam Pro" pitchFamily="34" charset="-122"/>
-                <a:cs typeface="Be Vietnam Pro" pitchFamily="34" charset="-120"/>
-              </a:rPr>
-              <a:t> Go.</a:t>
+              <a:rPr lang="en-US" sz="2700" dirty="0" spc="6" kern="0">
+                <a:solidFill>
+                  <a:srgbClr val="14161C"/>
+                </a:solidFill>
+                <a:latin typeface="Be Vietnam Pro" pitchFamily="34" charset="0"/>
+                <a:ea typeface="Be Vietnam Pro" pitchFamily="34" charset="-122"/>
+                <a:cs typeface="Be Vietnam Pro" pitchFamily="34" charset="-120"/>
+              </a:rPr>
+              <a:t> CPython</a:t>
+            </a:r>
+            <a:r>
+              <a:rPr lang="en-US" sz="2700" dirty="0" spc="-8" kern="0">
+                <a:solidFill>
+                  <a:srgbClr val="14161C"/>
+                </a:solidFill>
+                <a:latin typeface="Be Vietnam Pro" pitchFamily="34" charset="0"/>
+                <a:ea typeface="Be Vietnam Pro" pitchFamily="34" charset="-122"/>
+                <a:cs typeface="Be Vietnam Pro" pitchFamily="34" charset="-120"/>
+              </a:rPr>
+              <a:t> và Go.</a:t>
             </a:r>
             <a:endParaRPr lang="en-US" sz="2700" dirty="0"/>
           </a:p>
@@ -10410,7 +10388,7 @@
               <a:buNone/>
             </a:pPr>
             <a:r>
-              <a:rPr lang="en-US" sz="1950" b="1" spc="227" kern="0" dirty="0">
+              <a:rPr lang="en-US" sz="1950" b="1" spc="226" kern="0" dirty="0">
                 <a:solidFill>
                   <a:srgbClr val="B45309"/>
                 </a:solidFill>
@@ -10418,10 +10396,10 @@
                 <a:ea typeface="Be Vietnam Pro" pitchFamily="34" charset="-122"/>
                 <a:cs typeface="Be Vietnam Pro" pitchFamily="34" charset="-120"/>
               </a:rPr>
-              <a:t>PYTHON</a:t>
-            </a:r>
-            <a:r>
-              <a:rPr lang="en-US" sz="1950" b="1" spc="220" kern="0" dirty="0">
+              <a:t>CPYTHON</a:t>
+            </a:r>
+            <a:r>
+              <a:rPr lang="en-US" sz="1950" b="1" spc="221" kern="0" dirty="0">
                 <a:solidFill>
                   <a:srgbClr val="B45309"/>
                 </a:solidFill>
@@ -10443,7 +10421,7 @@
               <a:t> HAI</a:t>
             </a:r>
             <a:r>
-              <a:rPr lang="en-US" sz="1950" b="1" spc="204" kern="0" dirty="0">
+              <a:rPr lang="en-US" sz="1950" b="1" spc="203" kern="0" dirty="0">
                 <a:solidFill>
                   <a:srgbClr val="B45309"/>
                 </a:solidFill>
@@ -10485,7 +10463,7 @@
               <a:buNone/>
             </a:pPr>
             <a:r>
-              <a:rPr lang="en-US" sz="7800" dirty="0" spc="6" kern="0">
+              <a:rPr lang="en-US" sz="7800" dirty="0" spc="5" kern="0">
                 <a:solidFill>
                   <a:srgbClr val="14161C"/>
                 </a:solidFill>
@@ -10493,7 +10471,7 @@
                 <a:ea typeface="Bricolage Grotesque ExtraBold" pitchFamily="34" charset="-122"/>
                 <a:cs typeface="Bricolage Grotesque ExtraBold" pitchFamily="34" charset="-120"/>
               </a:rPr>
-              <a:t>Python:</a:t>
+              <a:t>CPython:</a:t>
             </a:r>
             <a:r>
               <a:rPr lang="en-US" sz="7800" dirty="0" spc="-1" kern="0">
@@ -17165,7 +17143,7 @@
               <a:buNone/>
             </a:pPr>
             <a:r>
-              <a:rPr lang="en-US" sz="3900" dirty="0" spc="5" kern="0">
+              <a:rPr lang="en-US" sz="3900" dirty="0" spc="4" kern="0">
                 <a:solidFill>
                   <a:srgbClr val="B45309"/>
                 </a:solidFill>
@@ -17173,7 +17151,7 @@
                 <a:ea typeface="Bricolage Grotesque ExtraBold" pitchFamily="34" charset="-122"/>
                 <a:cs typeface="Bricolage Grotesque ExtraBold" pitchFamily="34" charset="-120"/>
               </a:rPr>
-              <a:t>Python</a:t>
+              <a:t>CPython</a:t>
             </a:r>
             <a:endParaRPr lang="en-US" sz="3900" dirty="0"/>
           </a:p>
@@ -17884,7 +17862,192 @@
       </p:sp>
       <p:sp>
         <p:nvSpPr>
-          <p:cNvPr id="32" name="Shape 30"/>
+          <p:cNvPr id="32" name="Text 30"/>
+          <p:cNvSpPr/>
+          <p:nvPr/>
+        </p:nvSpPr>
+        <p:spPr>
+          <a:xfrm>
+            <a:off x="914400" y="5448300"/>
+            <a:ext cx="7810500" cy="800100"/>
+          </a:xfrm>
+          <a:prstGeom prst="rect">
+            <a:avLst/>
+          </a:prstGeom>
+          <a:noFill/>
+          <a:ln/>
+        </p:spPr>
+        <p:txBody>
+          <a:bodyPr wrap="square" lIns="0" tIns="4667" rIns="0" bIns="-4667" rtlCol="0" anchor="t"/>
+          <a:lstStyle/>
+          <a:p>
+            <a:pPr algn="l" indent="0" marL="0">
+              <a:lnSpc>
+                <a:spcPts val="2940"/>
+              </a:lnSpc>
+              <a:buNone/>
+            </a:pPr>
+            <a:r>
+              <a:rPr lang="en-US" sz="2100" dirty="0" spc="3" kern="0">
+                <a:solidFill>
+                  <a:srgbClr val="6B6A66"/>
+                </a:solidFill>
+                <a:latin typeface="Be Vietnam Pro" pitchFamily="34" charset="0"/>
+                <a:ea typeface="Be Vietnam Pro" pitchFamily="34" charset="-122"/>
+                <a:cs typeface="Be Vietnam Pro" pitchFamily="34" charset="-120"/>
+              </a:rPr>
+              <a:t>Đếm</a:t>
+            </a:r>
+            <a:r>
+              <a:rPr lang="en-US" sz="2100" dirty="0" spc="-2" kern="0">
+                <a:solidFill>
+                  <a:srgbClr val="6B6A66"/>
+                </a:solidFill>
+                <a:latin typeface="Be Vietnam Pro" pitchFamily="34" charset="0"/>
+                <a:ea typeface="Be Vietnam Pro" pitchFamily="34" charset="-122"/>
+                <a:cs typeface="Be Vietnam Pro" pitchFamily="34" charset="-120"/>
+              </a:rPr>
+              <a:t> tham</a:t>
+            </a:r>
+            <a:r>
+              <a:rPr lang="en-US" sz="2100" dirty="0" spc="1" kern="0">
+                <a:solidFill>
+                  <a:srgbClr val="6B6A66"/>
+                </a:solidFill>
+                <a:latin typeface="Be Vietnam Pro" pitchFamily="34" charset="0"/>
+                <a:ea typeface="Be Vietnam Pro" pitchFamily="34" charset="-122"/>
+                <a:cs typeface="Be Vietnam Pro" pitchFamily="34" charset="-120"/>
+              </a:rPr>
+              <a:t> chiếu</a:t>
+            </a:r>
+            <a:r>
+              <a:rPr lang="en-US" sz="2100" dirty="0" spc="-3" kern="0">
+                <a:solidFill>
+                  <a:srgbClr val="6B6A66"/>
+                </a:solidFill>
+                <a:latin typeface="Be Vietnam Pro" pitchFamily="34" charset="0"/>
+                <a:ea typeface="Be Vietnam Pro" pitchFamily="34" charset="-122"/>
+                <a:cs typeface="Be Vietnam Pro" pitchFamily="34" charset="-120"/>
+              </a:rPr>
+              <a:t> là</a:t>
+            </a:r>
+            <a:r>
+              <a:rPr lang="en-US" sz="2100" dirty="0" spc="-2" kern="0">
+                <a:solidFill>
+                  <a:srgbClr val="6B6A66"/>
+                </a:solidFill>
+                <a:latin typeface="Be Vietnam Pro" pitchFamily="34" charset="0"/>
+                <a:ea typeface="Be Vietnam Pro" pitchFamily="34" charset="-122"/>
+                <a:cs typeface="Be Vietnam Pro" pitchFamily="34" charset="-120"/>
+              </a:rPr>
+              <a:t> cách</a:t>
+            </a:r>
+            <a:r>
+              <a:rPr lang="en-US" sz="2100" dirty="0" spc="-1" kern="0">
+                <a:solidFill>
+                  <a:srgbClr val="6B6A66"/>
+                </a:solidFill>
+                <a:latin typeface="Be Vietnam Pro" pitchFamily="34" charset="0"/>
+                <a:ea typeface="Be Vietnam Pro" pitchFamily="34" charset="-122"/>
+                <a:cs typeface="Be Vietnam Pro" pitchFamily="34" charset="-120"/>
+              </a:rPr>
+              <a:t> của</a:t>
+            </a:r>
+            <a:r>
+              <a:rPr lang="en-US" sz="2100" dirty="0" spc="5" kern="0">
+                <a:solidFill>
+                  <a:srgbClr val="6B6A66"/>
+                </a:solidFill>
+                <a:latin typeface="Be Vietnam Pro" pitchFamily="34" charset="0"/>
+                <a:ea typeface="Be Vietnam Pro" pitchFamily="34" charset="-122"/>
+                <a:cs typeface="Be Vietnam Pro" pitchFamily="34" charset="-120"/>
+              </a:rPr>
+              <a:t> CPython,</a:t>
+            </a:r>
+            <a:r>
+              <a:rPr lang="en-US" sz="2100" dirty="0" spc="-1" kern="0">
+                <a:solidFill>
+                  <a:srgbClr val="6B6A66"/>
+                </a:solidFill>
+                <a:latin typeface="Be Vietnam Pro" pitchFamily="34" charset="0"/>
+                <a:ea typeface="Be Vietnam Pro" pitchFamily="34" charset="-122"/>
+                <a:cs typeface="Be Vietnam Pro" pitchFamily="34" charset="-120"/>
+              </a:rPr>
+              <a:t> không</a:t>
+            </a:r>
+            <a:r>
+              <a:rPr lang="en-US" sz="2100" dirty="0" spc="-3" kern="0">
+                <a:solidFill>
+                  <a:srgbClr val="6B6A66"/>
+                </a:solidFill>
+                <a:latin typeface="Be Vietnam Pro" pitchFamily="34" charset="0"/>
+                <a:ea typeface="Be Vietnam Pro" pitchFamily="34" charset="-122"/>
+                <a:cs typeface="Be Vietnam Pro" pitchFamily="34" charset="-120"/>
+              </a:rPr>
+              <a:t> phải</a:t>
+            </a:r>
+            <a:r>
+              <a:rPr lang="en-US" sz="2100" dirty="0" spc="-6" kern="0">
+                <a:solidFill>
+                  <a:srgbClr val="6B6A66"/>
+                </a:solidFill>
+                <a:latin typeface="Be Vietnam Pro" pitchFamily="34" charset="0"/>
+                <a:ea typeface="Be Vietnam Pro" pitchFamily="34" charset="-122"/>
+                <a:cs typeface="Be Vietnam Pro" pitchFamily="34" charset="-120"/>
+              </a:rPr>
+              <a:t> bảo</a:t>
+            </a:r>
+            <a:r>
+              <a:rPr lang="en-US" sz="2100" dirty="0" spc="9" kern="0">
+                <a:solidFill>
+                  <a:srgbClr val="6B6A66"/>
+                </a:solidFill>
+                <a:latin typeface="Be Vietnam Pro" pitchFamily="34" charset="0"/>
+                <a:ea typeface="Be Vietnam Pro" pitchFamily="34" charset="-122"/>
+                <a:cs typeface="Be Vietnam Pro" pitchFamily="34" charset="-120"/>
+              </a:rPr>
+              <a:t> đảm</a:t>
+            </a:r>
+            <a:r>
+              <a:rPr lang="en-US" sz="2100" dirty="0" spc="-1" kern="0">
+                <a:solidFill>
+                  <a:srgbClr val="6B6A66"/>
+                </a:solidFill>
+                <a:latin typeface="Be Vietnam Pro" pitchFamily="34" charset="0"/>
+                <a:ea typeface="Be Vietnam Pro" pitchFamily="34" charset="-122"/>
+                <a:cs typeface="Be Vietnam Pro" pitchFamily="34" charset="-120"/>
+              </a:rPr>
+              <a:t> của mọi</a:t>
+            </a:r>
+            <a:r>
+              <a:rPr lang="en-US" sz="2100" dirty="0" spc="-5" kern="0">
+                <a:solidFill>
+                  <a:srgbClr val="6B6A66"/>
+                </a:solidFill>
+                <a:latin typeface="Be Vietnam Pro" pitchFamily="34" charset="0"/>
+                <a:ea typeface="Be Vietnam Pro" pitchFamily="34" charset="-122"/>
+                <a:cs typeface="Be Vietnam Pro" pitchFamily="34" charset="-120"/>
+              </a:rPr>
+              <a:t> bản</a:t>
+            </a:r>
+            <a:r>
+              <a:rPr lang="en-US" sz="2100" dirty="0" spc="5" kern="0">
+                <a:solidFill>
+                  <a:srgbClr val="6B6A66"/>
+                </a:solidFill>
+                <a:latin typeface="Be Vietnam Pro" pitchFamily="34" charset="0"/>
+                <a:ea typeface="Be Vietnam Pro" pitchFamily="34" charset="-122"/>
+                <a:cs typeface="Be Vietnam Pro" pitchFamily="34" charset="-120"/>
+              </a:rPr>
+              <a:t> Python.</a:t>
+            </a:r>
+            <a:endParaRPr lang="en-US" sz="2100" dirty="0"/>
+          </a:p>
+        </p:txBody>
+      </p:sp>
+      <p:sp>
+        <p:nvSpPr>
+          <p:cNvPr id="33" name="Shape 31"/>
           <p:cNvSpPr/>
           <p:nvPr/>
         </p:nvSpPr>
@@ -17908,7 +18071,7 @@
       </p:sp>
       <p:pic>
         <p:nvPicPr>
-          <p:cNvPr id="33" name="Moda image moda-export-watermark-5388403f-379d-400b-a793-f218b96509ae" descr="">    </p:cNvPr>
+          <p:cNvPr id="34" name="Moda image moda-export-watermark-5388403f-379d-400b-a793-f218b96509ae" descr="">    </p:cNvPr>
           <p:cNvPicPr>
             <a:picLocks noChangeAspect="1"/>
           </p:cNvPicPr>
@@ -18177,18 +18340,29 @@
                 <a:ea typeface="Be Vietnam Pro" pitchFamily="34" charset="-122"/>
                 <a:cs typeface="Be Vietnam Pro" pitchFamily="34" charset="-120"/>
               </a:rPr>
-              <a:t> Python,</a:t>
-            </a:r>
-            <a:r>
-              <a:rPr lang="en-US" sz="2700" dirty="0" spc="-2" kern="0">
-                <a:solidFill>
-                  <a:srgbClr val="14161C"/>
-                </a:solidFill>
-                <a:latin typeface="Be Vietnam Pro" pitchFamily="34" charset="0"/>
-                <a:ea typeface="Be Vietnam Pro" pitchFamily="34" charset="-122"/>
-                <a:cs typeface="Be Vietnam Pro" pitchFamily="34" charset="-120"/>
-              </a:rPr>
-              <a:t> không còn</a:t>
+              <a:t> CPython,</a:t>
+            </a:r>
+            <a:r>
+              <a:rPr lang="en-US" sz="2700" dirty="0" spc="-3" kern="0">
+                <a:solidFill>
+                  <a:srgbClr val="14161C"/>
+                </a:solidFill>
+                <a:latin typeface="Be Vietnam Pro" pitchFamily="34" charset="0"/>
+                <a:ea typeface="Be Vietnam Pro" pitchFamily="34" charset="-122"/>
+                <a:cs typeface="Be Vietnam Pro" pitchFamily="34" charset="-120"/>
+              </a:rPr>
+              <a:t> không</a:t>
+            </a:r>
+            <a:r>
+              <a:rPr lang="en-US" sz="2700" dirty="0" spc="-1" kern="0">
+                <a:solidFill>
+                  <a:srgbClr val="14161C"/>
+                </a:solidFill>
+                <a:latin typeface="Be Vietnam Pro" pitchFamily="34" charset="0"/>
+                <a:ea typeface="Be Vietnam Pro" pitchFamily="34" charset="-122"/>
+                <a:cs typeface="Be Vietnam Pro" pitchFamily="34" charset="-120"/>
+              </a:rPr>
+              <a:t> còn</a:t>
             </a:r>
             <a:r>
               <a:rPr lang="en-US" sz="2700" dirty="0" spc="-3" kern="0">

</xml_diff>

<commit_message>
Lesson sd-10-002: scope the Go description to the standard toolchain, with the deck and figure to match
Co-Authored-By: Claude Sonnet 5.5 <noreply@anthropic.com>
Claude-Session: https://claude.ai/code/session_01E4oCkXXqBf2c7oMUzFxEr2
</commit_message>
<xml_diff>
--- a/system-design-101/vi/lessons/sd-10-002/slides/sd-10-002.pptx
+++ b/system-design-101/vi/lessons/sd-10-002/slides/sd-10-002.pptx
@@ -12381,7 +12381,18 @@
               <a:t>GO</a:t>
             </a:r>
             <a:r>
-              <a:rPr lang="en-US" sz="1950" b="1" spc="221" kern="0" dirty="0">
+              <a:rPr lang="en-US" sz="1950" b="1" spc="216" kern="0" dirty="0">
+                <a:solidFill>
+                  <a:srgbClr val="0F766E"/>
+                </a:solidFill>
+                <a:latin typeface="Be Vietnam Pro" pitchFamily="34" charset="0"/>
+                <a:ea typeface="Be Vietnam Pro" pitchFamily="34" charset="-122"/>
+                <a:cs typeface="Be Vietnam Pro" pitchFamily="34" charset="-120"/>
+              </a:rPr>
+              <a:t> CHUẨN</a:t>
+            </a:r>
+            <a:r>
+              <a:rPr lang="en-US" sz="1950" b="1" spc="223" kern="0" dirty="0">
                 <a:solidFill>
                   <a:srgbClr val="0F766E"/>
                 </a:solidFill>
@@ -12489,6 +12500,72 @@
               <a:t> dọn</a:t>
             </a:r>
             <a:r>
+              <a:rPr lang="en-US" sz="2850" dirty="0" spc="1" kern="0">
+                <a:solidFill>
+                  <a:srgbClr val="14161C"/>
+                </a:solidFill>
+                <a:latin typeface="Be Vietnam Pro" pitchFamily="34" charset="0"/>
+                <a:ea typeface="Be Vietnam Pro" pitchFamily="34" charset="-122"/>
+                <a:cs typeface="Be Vietnam Pro" pitchFamily="34" charset="-120"/>
+              </a:rPr>
+              <a:t> của</a:t>
+            </a:r>
+            <a:r>
+              <a:rPr lang="en-US" sz="2850" dirty="0" spc="-6" kern="0">
+                <a:solidFill>
+                  <a:srgbClr val="14161C"/>
+                </a:solidFill>
+                <a:latin typeface="Be Vietnam Pro" pitchFamily="34" charset="0"/>
+                <a:ea typeface="Be Vietnam Pro" pitchFamily="34" charset="-122"/>
+                <a:cs typeface="Be Vietnam Pro" pitchFamily="34" charset="-120"/>
+              </a:rPr>
+              <a:t> bộ</a:t>
+            </a:r>
+            <a:r>
+              <a:rPr lang="en-US" sz="2850" dirty="0" spc="-2" kern="0">
+                <a:solidFill>
+                  <a:srgbClr val="14161C"/>
+                </a:solidFill>
+                <a:latin typeface="Be Vietnam Pro" pitchFamily="34" charset="0"/>
+                <a:ea typeface="Be Vietnam Pro" pitchFamily="34" charset="-122"/>
+                <a:cs typeface="Be Vietnam Pro" pitchFamily="34" charset="-120"/>
+              </a:rPr>
+              <a:t> công</a:t>
+            </a:r>
+            <a:r>
+              <a:rPr lang="en-US" sz="2850" dirty="0" spc="0" kern="0">
+                <a:solidFill>
+                  <a:srgbClr val="14161C"/>
+                </a:solidFill>
+                <a:latin typeface="Be Vietnam Pro" pitchFamily="34" charset="0"/>
+                <a:ea typeface="Be Vietnam Pro" pitchFamily="34" charset="-122"/>
+                <a:cs typeface="Be Vietnam Pro" pitchFamily="34" charset="-120"/>
+              </a:rPr>
+              <a:t> cụ</a:t>
+            </a:r>
+            <a:r>
+              <a:rPr lang="en-US" sz="2850" dirty="0" spc="1" kern="0">
+                <a:solidFill>
+                  <a:srgbClr val="14161C"/>
+                </a:solidFill>
+                <a:latin typeface="Be Vietnam Pro" pitchFamily="34" charset="0"/>
+                <a:ea typeface="Be Vietnam Pro" pitchFamily="34" charset="-122"/>
+                <a:cs typeface="Be Vietnam Pro" pitchFamily="34" charset="-120"/>
+              </a:rPr>
+              <a:t> Go</a:t>
+            </a:r>
+            <a:r>
+              <a:rPr lang="en-US" sz="2850" dirty="0" spc="-1" kern="0">
+                <a:solidFill>
+                  <a:srgbClr val="14161C"/>
+                </a:solidFill>
+                <a:latin typeface="Be Vietnam Pro" pitchFamily="34" charset="0"/>
+                <a:ea typeface="Be Vietnam Pro" pitchFamily="34" charset="-122"/>
+                <a:cs typeface="Be Vietnam Pro" pitchFamily="34" charset="-120"/>
+              </a:rPr>
+              <a:t> chuẩn</a:t>
+            </a:r>
+            <a:r>
               <a:rPr lang="en-US" sz="2850" dirty="0" spc="11" kern="0">
                 <a:solidFill>
                   <a:srgbClr val="14161C"/>
@@ -12500,7 +12577,7 @@
               <a:t> đánh</a:t>
             </a:r>
             <a:r>
-              <a:rPr lang="en-US" sz="2850" dirty="0" spc="0" kern="0">
+              <a:rPr lang="en-US" sz="2850" dirty="0" spc="1" kern="0">
                 <a:solidFill>
                   <a:srgbClr val="14161C"/>
                 </a:solidFill>
@@ -12511,7 +12588,7 @@
               <a:t> dấu</a:t>
             </a:r>
             <a:r>
-              <a:rPr lang="en-US" sz="2850" dirty="0" spc="-26" kern="0">
+              <a:rPr lang="en-US" sz="2850" dirty="0" spc="-27" kern="0">
                 <a:solidFill>
                   <a:srgbClr val="14161C"/>
                 </a:solidFill>
@@ -12522,7 +12599,7 @@
               <a:t> rồi</a:t>
             </a:r>
             <a:r>
-              <a:rPr lang="en-US" sz="2850" dirty="0" spc="-6" kern="0">
+              <a:rPr lang="en-US" sz="2850" dirty="0" spc="-5" kern="0">
                 <a:solidFill>
                   <a:srgbClr val="14161C"/>
                 </a:solidFill>
@@ -12533,15 +12610,15 @@
               <a:t> quét,</a:t>
             </a:r>
             <a:r>
-              <a:rPr lang="en-US" sz="2850" dirty="0" spc="-16" kern="0">
-                <a:solidFill>
-                  <a:srgbClr val="14161C"/>
-                </a:solidFill>
-                <a:latin typeface="Be Vietnam Pro" pitchFamily="34" charset="0"/>
-                <a:ea typeface="Be Vietnam Pro" pitchFamily="34" charset="-122"/>
-                <a:cs typeface="Be Vietnam Pro" pitchFamily="34" charset="-120"/>
-              </a:rPr>
-              <a:t> và</a:t>
+              <a:rPr lang="en-US" sz="2850" dirty="0" spc="-1" kern="0">
+                <a:solidFill>
+                  <a:srgbClr val="14161C"/>
+                </a:solidFill>
+                <a:latin typeface="Be Vietnam Pro" pitchFamily="34" charset="0"/>
+                <a:ea typeface="Be Vietnam Pro" pitchFamily="34" charset="-122"/>
+                <a:cs typeface="Be Vietnam Pro" pitchFamily="34" charset="-120"/>
+              </a:rPr>
+              <a:t> phần lớn</a:t>
             </a:r>
             <a:r>
               <a:rPr lang="en-US" sz="2850" dirty="0" spc="-9" kern="0">
@@ -12566,7 +12643,7 @@
               <a:t> đồng</a:t>
             </a:r>
             <a:r>
-              <a:rPr lang="en-US" sz="2850" dirty="0" spc="0" kern="0">
+              <a:rPr lang="en-US" sz="2850" dirty="0" spc="-1" kern="0">
                 <a:solidFill>
                   <a:srgbClr val="14161C"/>
                 </a:solidFill>
@@ -12577,7 +12654,7 @@
               <a:t> thời</a:t>
             </a:r>
             <a:r>
-              <a:rPr lang="en-US" sz="2850" dirty="0" spc="-13" kern="0">
+              <a:rPr lang="en-US" sz="2850" dirty="0" spc="-12" kern="0">
                 <a:solidFill>
                   <a:srgbClr val="14161C"/>
                 </a:solidFill>
@@ -12599,7 +12676,7 @@
               <a:t> ứng</a:t>
             </a:r>
             <a:r>
-              <a:rPr lang="en-US" sz="2850" dirty="0" spc="-2" kern="0">
+              <a:rPr lang="en-US" sz="2850" dirty="0" spc="-1" kern="0">
                 <a:solidFill>
                   <a:srgbClr val="14161C"/>
                 </a:solidFill>
@@ -12779,6 +12856,28 @@
               <a:t> toàn</a:t>
             </a:r>
             <a:r>
+              <a:rPr lang="en-US" sz="2550" dirty="0" spc="-2" kern="0">
+                <a:solidFill>
+                  <a:srgbClr val="14161C"/>
+                </a:solidFill>
+                <a:latin typeface="Be Vietnam Pro" pitchFamily="34" charset="0"/>
+                <a:ea typeface="Be Vietnam Pro" pitchFamily="34" charset="-122"/>
+                <a:cs typeface="Be Vietnam Pro" pitchFamily="34" charset="-120"/>
+              </a:rPr>
+              <a:t> bộ:</a:t>
+            </a:r>
+            <a:r>
+              <a:rPr lang="en-US" sz="2550" dirty="0" spc="0" kern="0">
+                <a:solidFill>
+                  <a:srgbClr val="14161C"/>
+                </a:solidFill>
+                <a:latin typeface="Be Vietnam Pro" pitchFamily="34" charset="0"/>
+                <a:ea typeface="Be Vietnam Pro" pitchFamily="34" charset="-122"/>
+                <a:cs typeface="Be Vietnam Pro" pitchFamily="34" charset="-120"/>
+              </a:rPr>
+              <a:t> phần lớn</a:t>
+            </a:r>
+            <a:r>
               <a:rPr lang="en-US" sz="2550" dirty="0" spc="-4" kern="0">
                 <a:solidFill>
                   <a:srgbClr val="14161C"/>
@@ -12787,18 +12886,62 @@
                 <a:ea typeface="Be Vietnam Pro" pitchFamily="34" charset="-122"/>
                 <a:cs typeface="Be Vietnam Pro" pitchFamily="34" charset="-120"/>
               </a:rPr>
-              <a:t> bộ;</a:t>
-            </a:r>
-            <a:r>
-              <a:rPr lang="en-US" sz="2550" dirty="0" spc="1" kern="0">
-                <a:solidFill>
-                  <a:srgbClr val="14161C"/>
-                </a:solidFill>
-                <a:latin typeface="Be Vietnam Pro" pitchFamily="34" charset="0"/>
-                <a:ea typeface="Be Vietnam Pro" pitchFamily="34" charset="-122"/>
-                <a:cs typeface="Be Vietnam Pro" pitchFamily="34" charset="-120"/>
-              </a:rPr>
-              <a:t> làm</a:t>
+              <a:t> việc</a:t>
+            </a:r>
+            <a:r>
+              <a:rPr lang="en-US" sz="2550" dirty="0" spc="-8" kern="0">
+                <a:solidFill>
+                  <a:srgbClr val="14161C"/>
+                </a:solidFill>
+                <a:latin typeface="Be Vietnam Pro" pitchFamily="34" charset="0"/>
+                <a:ea typeface="Be Vietnam Pro" pitchFamily="34" charset="-122"/>
+                <a:cs typeface="Be Vietnam Pro" pitchFamily="34" charset="-120"/>
+              </a:rPr>
+              <a:t> chạy</a:t>
+            </a:r>
+            <a:r>
+              <a:rPr lang="en-US" sz="2550" dirty="0" spc="11" kern="0">
+                <a:solidFill>
+                  <a:srgbClr val="14161C"/>
+                </a:solidFill>
+                <a:latin typeface="Be Vietnam Pro" pitchFamily="34" charset="0"/>
+                <a:ea typeface="Be Vietnam Pro" pitchFamily="34" charset="-122"/>
+                <a:cs typeface="Be Vietnam Pro" pitchFamily="34" charset="-120"/>
+              </a:rPr>
+              <a:t> đồng</a:t>
+            </a:r>
+            <a:r>
+              <a:rPr lang="en-US" sz="2550" dirty="0" spc="-1" kern="0">
+                <a:solidFill>
+                  <a:srgbClr val="14161C"/>
+                </a:solidFill>
+                <a:latin typeface="Be Vietnam Pro" pitchFamily="34" charset="0"/>
+                <a:ea typeface="Be Vietnam Pro" pitchFamily="34" charset="-122"/>
+                <a:cs typeface="Be Vietnam Pro" pitchFamily="34" charset="-120"/>
+              </a:rPr>
+              <a:t> thời,</a:t>
+            </a:r>
+            <a:r>
+              <a:rPr lang="en-US" sz="2550" dirty="0" spc="16" kern="0">
+                <a:solidFill>
+                  <a:srgbClr val="14161C"/>
+                </a:solidFill>
+                <a:latin typeface="Be Vietnam Pro" pitchFamily="34" charset="0"/>
+                <a:ea typeface="Be Vietnam Pro" pitchFamily="34" charset="-122"/>
+                <a:cs typeface="Be Vietnam Pro" pitchFamily="34" charset="-120"/>
+              </a:rPr>
+              <a:t> nhưng</a:t>
+            </a:r>
+            <a:r>
+              <a:rPr lang="en-US" sz="2550" dirty="0" spc="-14" kern="0">
+                <a:solidFill>
+                  <a:srgbClr val="14161C"/>
+                </a:solidFill>
+                <a:latin typeface="Be Vietnam Pro" pitchFamily="34" charset="0"/>
+                <a:ea typeface="Be Vietnam Pro" pitchFamily="34" charset="-122"/>
+                <a:cs typeface="Be Vietnam Pro" pitchFamily="34" charset="-120"/>
+              </a:rPr>
+              <a:t> vẫn</a:t>
             </a:r>
             <a:r>
               <a:rPr lang="en-US" sz="2550" dirty="0" spc="0" kern="0">
@@ -12809,40 +12952,29 @@
                 <a:ea typeface="Be Vietnam Pro" pitchFamily="34" charset="-122"/>
                 <a:cs typeface="Be Vietnam Pro" pitchFamily="34" charset="-120"/>
               </a:rPr>
-              <a:t> phần lớn</a:t>
-            </a:r>
-            <a:r>
-              <a:rPr lang="en-US" sz="2550" dirty="0" spc="-4" kern="0">
-                <a:solidFill>
-                  <a:srgbClr val="14161C"/>
-                </a:solidFill>
-                <a:latin typeface="Be Vietnam Pro" pitchFamily="34" charset="0"/>
-                <a:ea typeface="Be Vietnam Pro" pitchFamily="34" charset="-122"/>
-                <a:cs typeface="Be Vietnam Pro" pitchFamily="34" charset="-120"/>
-              </a:rPr>
-              <a:t> việc</a:t>
-            </a:r>
-            <a:r>
-              <a:rPr lang="en-US" sz="2550" dirty="0" spc="11" kern="0">
-                <a:solidFill>
-                  <a:srgbClr val="14161C"/>
-                </a:solidFill>
-                <a:latin typeface="Be Vietnam Pro" pitchFamily="34" charset="0"/>
-                <a:ea typeface="Be Vietnam Pro" pitchFamily="34" charset="-122"/>
-                <a:cs typeface="Be Vietnam Pro" pitchFamily="34" charset="-120"/>
-              </a:rPr>
-              <a:t> đồng</a:t>
-            </a:r>
-            <a:r>
-              <a:rPr lang="en-US" sz="2550" dirty="0" spc="0" kern="0">
-                <a:solidFill>
-                  <a:srgbClr val="14161C"/>
-                </a:solidFill>
-                <a:latin typeface="Be Vietnam Pro" pitchFamily="34" charset="0"/>
-                <a:ea typeface="Be Vietnam Pro" pitchFamily="34" charset="-122"/>
-                <a:cs typeface="Be Vietnam Pro" pitchFamily="34" charset="-120"/>
-              </a:rPr>
-              <a:t> thời.</a:t>
+              <a:t> có</a:t>
+            </a:r>
+            <a:r>
+              <a:rPr lang="en-US" sz="2550" dirty="0" spc="-2" kern="0">
+                <a:solidFill>
+                  <a:srgbClr val="14161C"/>
+                </a:solidFill>
+                <a:latin typeface="Be Vietnam Pro" pitchFamily="34" charset="0"/>
+                <a:ea typeface="Be Vietnam Pro" pitchFamily="34" charset="-122"/>
+                <a:cs typeface="Be Vietnam Pro" pitchFamily="34" charset="-120"/>
+              </a:rPr>
+              <a:t> lúc</a:t>
+            </a:r>
+            <a:r>
+              <a:rPr lang="en-US" sz="2550" dirty="0" spc="17" kern="0">
+                <a:solidFill>
+                  <a:srgbClr val="14161C"/>
+                </a:solidFill>
+                <a:latin typeface="Be Vietnam Pro" pitchFamily="34" charset="0"/>
+                <a:ea typeface="Be Vietnam Pro" pitchFamily="34" charset="-122"/>
+                <a:cs typeface="Be Vietnam Pro" pitchFamily="34" charset="-120"/>
+              </a:rPr>
+              <a:t> dừng.</a:t>
             </a:r>
             <a:endParaRPr lang="en-US" sz="2550" dirty="0"/>
           </a:p>
@@ -13387,7 +13519,18 @@
                 <a:ea typeface="Be Vietnam Pro" pitchFamily="34" charset="-122"/>
                 <a:cs typeface="Be Vietnam Pro" pitchFamily="34" charset="-120"/>
               </a:rPr>
-              <a:t> VẪN CHẠY</a:t>
+              <a:t> CHẠY</a:t>
+            </a:r>
+            <a:r>
+              <a:rPr lang="en-US" sz="1950" b="1" spc="149" kern="0" dirty="0">
+                <a:solidFill>
+                  <a:srgbClr val="0F766E"/>
+                </a:solidFill>
+                <a:latin typeface="Be Vietnam Pro" pitchFamily="34" charset="0"/>
+                <a:ea typeface="Be Vietnam Pro" pitchFamily="34" charset="-122"/>
+                <a:cs typeface="Be Vietnam Pro" pitchFamily="34" charset="-120"/>
+              </a:rPr>
+              <a:t> TIẾP</a:t>
             </a:r>
             <a:endParaRPr lang="en-US" sz="1950" dirty="0"/>
           </a:p>
@@ -13455,6 +13598,28 @@
               <a:t> chạy</a:t>
             </a:r>
             <a:r>
+              <a:rPr lang="en-US" sz="2100" b="1" dirty="0" spc="-1" kern="0">
+                <a:solidFill>
+                  <a:srgbClr val="F3EEE3"/>
+                </a:solidFill>
+                <a:latin typeface="Be Vietnam Pro" pitchFamily="34" charset="0"/>
+                <a:ea typeface="Be Vietnam Pro" pitchFamily="34" charset="-122"/>
+                <a:cs typeface="Be Vietnam Pro" pitchFamily="34" charset="-120"/>
+              </a:rPr>
+              <a:t> phần</a:t>
+            </a:r>
+            <a:r>
+              <a:rPr lang="en-US" sz="2100" b="1" dirty="0" spc="-4" kern="0">
+                <a:solidFill>
+                  <a:srgbClr val="F3EEE3"/>
+                </a:solidFill>
+                <a:latin typeface="Be Vietnam Pro" pitchFamily="34" charset="0"/>
+                <a:ea typeface="Be Vietnam Pro" pitchFamily="34" charset="-122"/>
+                <a:cs typeface="Be Vietnam Pro" pitchFamily="34" charset="-120"/>
+              </a:rPr>
+              <a:t> lớn</a:t>
+            </a:r>
+            <a:r>
               <a:rPr lang="en-US" sz="2100" b="1" dirty="0" spc="-2" kern="0">
                 <a:solidFill>
                   <a:srgbClr val="F3EEE3"/>
@@ -13463,10 +13628,10 @@
                 <a:ea typeface="Be Vietnam Pro" pitchFamily="34" charset="-122"/>
                 <a:cs typeface="Be Vietnam Pro" pitchFamily="34" charset="-120"/>
               </a:rPr>
-              <a:t> liên</a:t>
-            </a:r>
-            <a:r>
-              <a:rPr lang="en-US" sz="2100" b="1" dirty="0" spc="-4" kern="0">
+              <a:t> thời</a:t>
+            </a:r>
+            <a:r>
+              <a:rPr lang="en-US" sz="2100" b="1" dirty="0" spc="-1" kern="0">
                 <a:solidFill>
                   <a:srgbClr val="F3EEE3"/>
                 </a:solidFill>
@@ -13474,7 +13639,7 @@
                 <a:ea typeface="Be Vietnam Pro" pitchFamily="34" charset="-122"/>
                 <a:cs typeface="Be Vietnam Pro" pitchFamily="34" charset="-120"/>
               </a:rPr>
-              <a:t> tục</a:t>
+              <a:t> gian</a:t>
             </a:r>
             <a:endParaRPr lang="en-US" sz="2100" dirty="0"/>
           </a:p>
@@ -13546,10 +13711,10 @@
                 <a:ea typeface="Be Vietnam Pro" pitchFamily="34" charset="-122"/>
                 <a:cs typeface="Be Vietnam Pro" pitchFamily="34" charset="-120"/>
               </a:rPr>
-              <a:t> dọn</a:t>
-            </a:r>
-            <a:r>
-              <a:rPr lang="en-US" sz="1950" dirty="0" spc="-8" kern="0">
+              <a:t> dọn làm</a:t>
+            </a:r>
+            <a:r>
+              <a:rPr lang="en-US" sz="1950" dirty="0" spc="0" kern="0">
                 <a:solidFill>
                   <a:srgbClr val="6B6A66"/>
                 </a:solidFill>
@@ -13557,7 +13722,29 @@
                 <a:ea typeface="Be Vietnam Pro" pitchFamily="34" charset="-122"/>
                 <a:cs typeface="Be Vietnam Pro" pitchFamily="34" charset="-120"/>
               </a:rPr>
-              <a:t> chạy</a:t>
+              <a:t> phần</a:t>
+            </a:r>
+            <a:r>
+              <a:rPr lang="en-US" sz="1950" dirty="0" spc="-1" kern="0">
+                <a:solidFill>
+                  <a:srgbClr val="6B6A66"/>
+                </a:solidFill>
+                <a:latin typeface="Be Vietnam Pro" pitchFamily="34" charset="0"/>
+                <a:ea typeface="Be Vietnam Pro" pitchFamily="34" charset="-122"/>
+                <a:cs typeface="Be Vietnam Pro" pitchFamily="34" charset="-120"/>
+              </a:rPr>
+              <a:t> lớn</a:t>
+            </a:r>
+            <a:r>
+              <a:rPr lang="en-US" sz="1950" dirty="0" spc="-3" kern="0">
+                <a:solidFill>
+                  <a:srgbClr val="6B6A66"/>
+                </a:solidFill>
+                <a:latin typeface="Be Vietnam Pro" pitchFamily="34" charset="0"/>
+                <a:ea typeface="Be Vietnam Pro" pitchFamily="34" charset="-122"/>
+                <a:cs typeface="Be Vietnam Pro" pitchFamily="34" charset="-120"/>
+              </a:rPr>
+              <a:t> việc</a:t>
             </a:r>
             <a:r>
               <a:rPr lang="en-US" sz="1950" dirty="0" spc="1" kern="0">
@@ -13571,7 +13758,7 @@
               <a:t> cùng</a:t>
             </a:r>
             <a:r>
-              <a:rPr lang="en-US" sz="1950" dirty="0" spc="0" kern="0">
+              <a:rPr lang="en-US" sz="1950" dirty="0" spc="-1" kern="0">
                 <a:solidFill>
                   <a:srgbClr val="6B6A66"/>
                 </a:solidFill>
@@ -13579,10 +13766,10 @@
                 <a:ea typeface="Be Vietnam Pro" pitchFamily="34" charset="-122"/>
                 <a:cs typeface="Be Vietnam Pro" pitchFamily="34" charset="-120"/>
               </a:rPr>
-              <a:t> lúc,</a:t>
-            </a:r>
-            <a:r>
-              <a:rPr lang="en-US" sz="1950" dirty="0" spc="-1" kern="0">
+              <a:t> lúc;</a:t>
+            </a:r>
+            <a:r>
+              <a:rPr lang="en-US" sz="1950" dirty="0" spc="-9" kern="0">
                 <a:solidFill>
                   <a:srgbClr val="6B6A66"/>
                 </a:solidFill>
@@ -13590,10 +13777,10 @@
                 <a:ea typeface="Be Vietnam Pro" pitchFamily="34" charset="-122"/>
                 <a:cs typeface="Be Vietnam Pro" pitchFamily="34" charset="-120"/>
               </a:rPr>
-              <a:t> không ép</a:t>
-            </a:r>
-            <a:r>
-              <a:rPr lang="en-US" sz="1950" dirty="0" spc="22" kern="0">
+              <a:t> vẫn</a:t>
+            </a:r>
+            <a:r>
+              <a:rPr lang="en-US" sz="1950" dirty="0" spc="-4" kern="0">
                 <a:solidFill>
                   <a:srgbClr val="6B6A66"/>
                 </a:solidFill>
@@ -13601,10 +13788,10 @@
                 <a:ea typeface="Be Vietnam Pro" pitchFamily="34" charset="-122"/>
                 <a:cs typeface="Be Vietnam Pro" pitchFamily="34" charset="-120"/>
               </a:rPr>
-              <a:t> ứng</a:t>
-            </a:r>
-            <a:r>
-              <a:rPr lang="en-US" sz="1950" dirty="0" spc="1" kern="0">
+              <a:t> có</a:t>
+            </a:r>
+            <a:r>
+              <a:rPr lang="en-US" sz="1950" dirty="0" spc="-2" kern="0">
                 <a:solidFill>
                   <a:srgbClr val="6B6A66"/>
                 </a:solidFill>
@@ -13612,10 +13799,10 @@
                 <a:ea typeface="Be Vietnam Pro" pitchFamily="34" charset="-122"/>
                 <a:cs typeface="Be Vietnam Pro" pitchFamily="34" charset="-120"/>
               </a:rPr>
-              <a:t> dụng</a:t>
-            </a:r>
-            <a:r>
-              <a:rPr lang="en-US" sz="1950" dirty="0" spc="16" kern="0">
+              <a:t> lúc</a:t>
+            </a:r>
+            <a:r>
+              <a:rPr lang="en-US" sz="1950" dirty="0" spc="17" kern="0">
                 <a:solidFill>
                   <a:srgbClr val="6B6A66"/>
                 </a:solidFill>
@@ -13623,18 +13810,7 @@
                 <a:ea typeface="Be Vietnam Pro" pitchFamily="34" charset="-122"/>
                 <a:cs typeface="Be Vietnam Pro" pitchFamily="34" charset="-120"/>
               </a:rPr>
-              <a:t> ngừng</a:t>
-            </a:r>
-            <a:r>
-              <a:rPr lang="en-US" sz="1950" dirty="0" spc="0" kern="0">
-                <a:solidFill>
-                  <a:srgbClr val="6B6A66"/>
-                </a:solidFill>
-                <a:latin typeface="Be Vietnam Pro" pitchFamily="34" charset="0"/>
-                <a:ea typeface="Be Vietnam Pro" pitchFamily="34" charset="-122"/>
-                <a:cs typeface="Be Vietnam Pro" pitchFamily="34" charset="-120"/>
-              </a:rPr>
-              <a:t> hẳn</a:t>
+              <a:t> dừng</a:t>
             </a:r>
             <a:endParaRPr lang="en-US" sz="1950" dirty="0"/>
           </a:p>
@@ -17349,6 +17525,17 @@
               </a:rPr>
               <a:t>Go</a:t>
             </a:r>
+            <a:r>
+              <a:rPr lang="en-US" sz="3900" dirty="0" spc="3" kern="0">
+                <a:solidFill>
+                  <a:srgbClr val="0F766E"/>
+                </a:solidFill>
+                <a:latin typeface="Bricolage Grotesque ExtraBold" pitchFamily="34" charset="0"/>
+                <a:ea typeface="Bricolage Grotesque ExtraBold" pitchFamily="34" charset="-122"/>
+                <a:cs typeface="Bricolage Grotesque ExtraBold" pitchFamily="34" charset="-120"/>
+              </a:rPr>
+              <a:t> chuẩn</a:t>
+            </a:r>
             <a:endParaRPr lang="en-US" sz="3900" dirty="0"/>
           </a:p>
         </p:txBody>
@@ -17425,6 +17612,28 @@
               <a:t> quét,</a:t>
             </a:r>
             <a:r>
+              <a:rPr lang="en-US" sz="2250" dirty="0" spc="1" kern="0">
+                <a:solidFill>
+                  <a:srgbClr val="14161C"/>
+                </a:solidFill>
+                <a:latin typeface="Be Vietnam Pro" pitchFamily="34" charset="0"/>
+                <a:ea typeface="Be Vietnam Pro" pitchFamily="34" charset="-122"/>
+                <a:cs typeface="Be Vietnam Pro" pitchFamily="34" charset="-120"/>
+              </a:rPr>
+              <a:t> phần</a:t>
+            </a:r>
+            <a:r>
+              <a:rPr lang="en-US" sz="2250" dirty="0" spc="2" kern="0">
+                <a:solidFill>
+                  <a:srgbClr val="14161C"/>
+                </a:solidFill>
+                <a:latin typeface="Be Vietnam Pro" pitchFamily="34" charset="0"/>
+                <a:ea typeface="Be Vietnam Pro" pitchFamily="34" charset="-122"/>
+                <a:cs typeface="Be Vietnam Pro" pitchFamily="34" charset="-120"/>
+              </a:rPr>
+              <a:t> lớn</a:t>
+            </a:r>
+            <a:r>
               <a:rPr lang="en-US" sz="2250" dirty="0" spc="-6" kern="0">
                 <a:solidFill>
                   <a:srgbClr val="14161C"/>
@@ -17436,40 +17645,18 @@
               <a:t> chạy</a:t>
             </a:r>
             <a:r>
-              <a:rPr lang="en-US" sz="2250" dirty="0" spc="11" kern="0">
-                <a:solidFill>
-                  <a:srgbClr val="14161C"/>
-                </a:solidFill>
-                <a:latin typeface="Be Vietnam Pro" pitchFamily="34" charset="0"/>
-                <a:ea typeface="Be Vietnam Pro" pitchFamily="34" charset="-122"/>
-                <a:cs typeface="Be Vietnam Pro" pitchFamily="34" charset="-120"/>
-              </a:rPr>
-              <a:t> đồng</a:t>
-            </a:r>
-            <a:r>
-              <a:rPr lang="en-US" sz="2250" dirty="0" spc="0" kern="0">
-                <a:solidFill>
-                  <a:srgbClr val="14161C"/>
-                </a:solidFill>
-                <a:latin typeface="Be Vietnam Pro" pitchFamily="34" charset="0"/>
-                <a:ea typeface="Be Vietnam Pro" pitchFamily="34" charset="-122"/>
-                <a:cs typeface="Be Vietnam Pro" pitchFamily="34" charset="-120"/>
-              </a:rPr>
-              <a:t> thời</a:t>
-            </a:r>
-            <a:r>
-              <a:rPr lang="en-US" sz="2250" dirty="0" spc="-11" kern="0">
-                <a:solidFill>
-                  <a:srgbClr val="14161C"/>
-                </a:solidFill>
-                <a:latin typeface="Be Vietnam Pro" pitchFamily="34" charset="0"/>
-                <a:ea typeface="Be Vietnam Pro" pitchFamily="34" charset="-122"/>
-                <a:cs typeface="Be Vietnam Pro" pitchFamily="34" charset="-120"/>
-              </a:rPr>
-              <a:t> với</a:t>
-            </a:r>
-            <a:r>
-              <a:rPr lang="en-US" sz="2250" dirty="0" spc="25" kern="0">
+              <a:rPr lang="en-US" sz="2250" dirty="0" spc="3" kern="0">
+                <a:solidFill>
+                  <a:srgbClr val="14161C"/>
+                </a:solidFill>
+                <a:latin typeface="Be Vietnam Pro" pitchFamily="34" charset="0"/>
+                <a:ea typeface="Be Vietnam Pro" pitchFamily="34" charset="-122"/>
+                <a:cs typeface="Be Vietnam Pro" pitchFamily="34" charset="-120"/>
+              </a:rPr>
+              <a:t> cùng</a:t>
+            </a:r>
+            <a:r>
+              <a:rPr lang="en-US" sz="2250" dirty="0" spc="24" kern="0">
                 <a:solidFill>
                   <a:srgbClr val="14161C"/>
                 </a:solidFill>
@@ -17480,6 +17667,39 @@
               <a:t> ứng</a:t>
             </a:r>
             <a:r>
+              <a:rPr lang="en-US" sz="2250" dirty="0" spc="1" kern="0">
+                <a:solidFill>
+                  <a:srgbClr val="14161C"/>
+                </a:solidFill>
+                <a:latin typeface="Be Vietnam Pro" pitchFamily="34" charset="0"/>
+                <a:ea typeface="Be Vietnam Pro" pitchFamily="34" charset="-122"/>
+                <a:cs typeface="Be Vietnam Pro" pitchFamily="34" charset="-120"/>
+              </a:rPr>
+              <a:t> dụng;</a:t>
+            </a:r>
+            <a:r>
+              <a:rPr lang="en-US" sz="2250" dirty="0" spc="-12" kern="0">
+                <a:solidFill>
+                  <a:srgbClr val="14161C"/>
+                </a:solidFill>
+                <a:latin typeface="Be Vietnam Pro" pitchFamily="34" charset="0"/>
+                <a:ea typeface="Be Vietnam Pro" pitchFamily="34" charset="-122"/>
+                <a:cs typeface="Be Vietnam Pro" pitchFamily="34" charset="-120"/>
+              </a:rPr>
+              <a:t> vẫn</a:t>
+            </a:r>
+            <a:r>
+              <a:rPr lang="en-US" sz="2250" dirty="0" spc="5" kern="0">
+                <a:solidFill>
+                  <a:srgbClr val="14161C"/>
+                </a:solidFill>
+                <a:latin typeface="Be Vietnam Pro" pitchFamily="34" charset="0"/>
+                <a:ea typeface="Be Vietnam Pro" pitchFamily="34" charset="-122"/>
+                <a:cs typeface="Be Vietnam Pro" pitchFamily="34" charset="-120"/>
+              </a:rPr>
+              <a:t> có</a:t>
+            </a:r>
+            <a:r>
               <a:rPr lang="en-US" sz="2250" dirty="0" spc="3" kern="0">
                 <a:solidFill>
                   <a:srgbClr val="14161C"/>
@@ -17488,7 +17708,18 @@
                 <a:ea typeface="Be Vietnam Pro" pitchFamily="34" charset="-122"/>
                 <a:cs typeface="Be Vietnam Pro" pitchFamily="34" charset="-120"/>
               </a:rPr>
-              <a:t> dụng.</a:t>
+              <a:t> lúc</a:t>
+            </a:r>
+            <a:r>
+              <a:rPr lang="en-US" sz="2250" dirty="0" spc="18" kern="0">
+                <a:solidFill>
+                  <a:srgbClr val="14161C"/>
+                </a:solidFill>
+                <a:latin typeface="Be Vietnam Pro" pitchFamily="34" charset="0"/>
+                <a:ea typeface="Be Vietnam Pro" pitchFamily="34" charset="-122"/>
+                <a:cs typeface="Be Vietnam Pro" pitchFamily="34" charset="-120"/>
+              </a:rPr>
+              <a:t> dừng.</a:t>
             </a:r>
             <a:endParaRPr lang="en-US" sz="2250" dirty="0"/>
           </a:p>
@@ -17965,6 +18196,50 @@
               <a:t> CPython,</a:t>
             </a:r>
             <a:r>
+              <a:rPr lang="en-US" sz="2100" dirty="0" spc="-5" kern="0">
+                <a:solidFill>
+                  <a:srgbClr val="6B6A66"/>
+                </a:solidFill>
+                <a:latin typeface="Be Vietnam Pro" pitchFamily="34" charset="0"/>
+                <a:ea typeface="Be Vietnam Pro" pitchFamily="34" charset="-122"/>
+                <a:cs typeface="Be Vietnam Pro" pitchFamily="34" charset="-120"/>
+              </a:rPr>
+              <a:t> mô</a:t>
+            </a:r>
+            <a:r>
+              <a:rPr lang="en-US" sz="2100" dirty="0" spc="-17" kern="0">
+                <a:solidFill>
+                  <a:srgbClr val="6B6A66"/>
+                </a:solidFill>
+                <a:latin typeface="Be Vietnam Pro" pitchFamily="34" charset="0"/>
+                <a:ea typeface="Be Vietnam Pro" pitchFamily="34" charset="-122"/>
+                <a:cs typeface="Be Vietnam Pro" pitchFamily="34" charset="-120"/>
+              </a:rPr>
+              <a:t> tả</a:t>
+            </a:r>
+            <a:r>
+              <a:rPr lang="en-US" sz="2100" dirty="0" spc="-4" kern="0">
+                <a:solidFill>
+                  <a:srgbClr val="6B6A66"/>
+                </a:solidFill>
+                <a:latin typeface="Be Vietnam Pro" pitchFamily="34" charset="0"/>
+                <a:ea typeface="Be Vietnam Pro" pitchFamily="34" charset="-122"/>
+                <a:cs typeface="Be Vietnam Pro" pitchFamily="34" charset="-120"/>
+              </a:rPr>
+              <a:t> Go</a:t>
+            </a:r>
+            <a:r>
+              <a:rPr lang="en-US" sz="2100" dirty="0" spc="-3" kern="0">
+                <a:solidFill>
+                  <a:srgbClr val="6B6A66"/>
+                </a:solidFill>
+                <a:latin typeface="Be Vietnam Pro" pitchFamily="34" charset="0"/>
+                <a:ea typeface="Be Vietnam Pro" pitchFamily="34" charset="-122"/>
+                <a:cs typeface="Be Vietnam Pro" pitchFamily="34" charset="-120"/>
+              </a:rPr>
+              <a:t> là</a:t>
+            </a:r>
+            <a:r>
               <a:rPr lang="en-US" sz="2100" dirty="0" spc="-1" kern="0">
                 <a:solidFill>
                   <a:srgbClr val="6B6A66"/>
@@ -17973,7 +18248,73 @@
                 <a:ea typeface="Be Vietnam Pro" pitchFamily="34" charset="-122"/>
                 <a:cs typeface="Be Vietnam Pro" pitchFamily="34" charset="-120"/>
               </a:rPr>
-              <a:t> không</a:t>
+              <a:t> của</a:t>
+            </a:r>
+            <a:r>
+              <a:rPr lang="en-US" sz="2100" dirty="0" spc="-9" kern="0">
+                <a:solidFill>
+                  <a:srgbClr val="6B6A66"/>
+                </a:solidFill>
+                <a:latin typeface="Be Vietnam Pro" pitchFamily="34" charset="0"/>
+                <a:ea typeface="Be Vietnam Pro" pitchFamily="34" charset="-122"/>
+                <a:cs typeface="Be Vietnam Pro" pitchFamily="34" charset="-120"/>
+              </a:rPr>
+              <a:t> bộ</a:t>
+            </a:r>
+            <a:r>
+              <a:rPr lang="en-US" sz="2100" dirty="0" spc="-1" kern="0">
+                <a:solidFill>
+                  <a:srgbClr val="6B6A66"/>
+                </a:solidFill>
+                <a:latin typeface="Be Vietnam Pro" pitchFamily="34" charset="0"/>
+                <a:ea typeface="Be Vietnam Pro" pitchFamily="34" charset="-122"/>
+                <a:cs typeface="Be Vietnam Pro" pitchFamily="34" charset="-120"/>
+              </a:rPr>
+              <a:t> công cụ chuẩn;</a:t>
+            </a:r>
+            <a:r>
+              <a:rPr lang="en-US" sz="2100" dirty="0" spc="-5" kern="0">
+                <a:solidFill>
+                  <a:srgbClr val="6B6A66"/>
+                </a:solidFill>
+                <a:latin typeface="Be Vietnam Pro" pitchFamily="34" charset="0"/>
+                <a:ea typeface="Be Vietnam Pro" pitchFamily="34" charset="-122"/>
+                <a:cs typeface="Be Vietnam Pro" pitchFamily="34" charset="-120"/>
+              </a:rPr>
+              <a:t> bản</a:t>
+            </a:r>
+            <a:r>
+              <a:rPr lang="en-US" sz="2100" dirty="0" spc="-1" kern="0">
+                <a:solidFill>
+                  <a:srgbClr val="6B6A66"/>
+                </a:solidFill>
+                <a:latin typeface="Be Vietnam Pro" pitchFamily="34" charset="0"/>
+                <a:ea typeface="Be Vietnam Pro" pitchFamily="34" charset="-122"/>
+                <a:cs typeface="Be Vietnam Pro" pitchFamily="34" charset="-120"/>
+              </a:rPr>
+              <a:t> cài</a:t>
+            </a:r>
+            <a:r>
+              <a:rPr lang="en-US" sz="2100" dirty="0" spc="-2" kern="0">
+                <a:solidFill>
+                  <a:srgbClr val="6B6A66"/>
+                </a:solidFill>
+                <a:latin typeface="Be Vietnam Pro" pitchFamily="34" charset="0"/>
+                <a:ea typeface="Be Vietnam Pro" pitchFamily="34" charset="-122"/>
+                <a:cs typeface="Be Vietnam Pro" pitchFamily="34" charset="-120"/>
+              </a:rPr>
+              <a:t> đặt</a:t>
+            </a:r>
+            <a:r>
+              <a:rPr lang="en-US" sz="2100" dirty="0" spc="-1" kern="0">
+                <a:solidFill>
+                  <a:srgbClr val="6B6A66"/>
+                </a:solidFill>
+                <a:latin typeface="Be Vietnam Pro" pitchFamily="34" charset="0"/>
+                <a:ea typeface="Be Vietnam Pro" pitchFamily="34" charset="-122"/>
+                <a:cs typeface="Be Vietnam Pro" pitchFamily="34" charset="-120"/>
+              </a:rPr>
+              <a:t> khác</a:t>
             </a:r>
             <a:r>
               <a:rPr lang="en-US" sz="2100" dirty="0" spc="-3" kern="0">
@@ -17984,10 +18325,10 @@
                 <a:ea typeface="Be Vietnam Pro" pitchFamily="34" charset="-122"/>
                 <a:cs typeface="Be Vietnam Pro" pitchFamily="34" charset="-120"/>
               </a:rPr>
-              <a:t> phải</a:t>
-            </a:r>
-            <a:r>
-              <a:rPr lang="en-US" sz="2100" dirty="0" spc="-6" kern="0">
+              <a:t> có</a:t>
+            </a:r>
+            <a:r>
+              <a:rPr lang="en-US" sz="2100" dirty="0" spc="-1" kern="0">
                 <a:solidFill>
                   <a:srgbClr val="6B6A66"/>
                 </a:solidFill>
@@ -17995,10 +18336,10 @@
                 <a:ea typeface="Be Vietnam Pro" pitchFamily="34" charset="-122"/>
                 <a:cs typeface="Be Vietnam Pro" pitchFamily="34" charset="-120"/>
               </a:rPr>
-              <a:t> bảo</a:t>
-            </a:r>
-            <a:r>
-              <a:rPr lang="en-US" sz="2100" dirty="0" spc="9" kern="0">
+              <a:t> thể</a:t>
+            </a:r>
+            <a:r>
+              <a:rPr lang="en-US" sz="2100" dirty="0" spc="-2" kern="0">
                 <a:solidFill>
                   <a:srgbClr val="6B6A66"/>
                 </a:solidFill>
@@ -18006,7 +18347,7 @@
                 <a:ea typeface="Be Vietnam Pro" pitchFamily="34" charset="-122"/>
                 <a:cs typeface="Be Vietnam Pro" pitchFamily="34" charset="-120"/>
               </a:rPr>
-              <a:t> đảm</a:t>
+              <a:t> làm</a:t>
             </a:r>
             <a:r>
               <a:rPr lang="en-US" sz="2100" dirty="0" spc="-1" kern="0">
@@ -18017,29 +18358,7 @@
                 <a:ea typeface="Be Vietnam Pro" pitchFamily="34" charset="-122"/>
                 <a:cs typeface="Be Vietnam Pro" pitchFamily="34" charset="-120"/>
               </a:rPr>
-              <a:t> của mọi</a:t>
-            </a:r>
-            <a:r>
-              <a:rPr lang="en-US" sz="2100" dirty="0" spc="-5" kern="0">
-                <a:solidFill>
-                  <a:srgbClr val="6B6A66"/>
-                </a:solidFill>
-                <a:latin typeface="Be Vietnam Pro" pitchFamily="34" charset="0"/>
-                <a:ea typeface="Be Vietnam Pro" pitchFamily="34" charset="-122"/>
-                <a:cs typeface="Be Vietnam Pro" pitchFamily="34" charset="-120"/>
-              </a:rPr>
-              <a:t> bản</a:t>
-            </a:r>
-            <a:r>
-              <a:rPr lang="en-US" sz="2100" dirty="0" spc="5" kern="0">
-                <a:solidFill>
-                  <a:srgbClr val="6B6A66"/>
-                </a:solidFill>
-                <a:latin typeface="Be Vietnam Pro" pitchFamily="34" charset="0"/>
-                <a:ea typeface="Be Vietnam Pro" pitchFamily="34" charset="-122"/>
-                <a:cs typeface="Be Vietnam Pro" pitchFamily="34" charset="-120"/>
-              </a:rPr>
-              <a:t> Python.</a:t>
+              <a:t> khác.</a:t>
             </a:r>
             <a:endParaRPr lang="en-US" sz="2100" dirty="0"/>
           </a:p>

</xml_diff>

<commit_message>
Lessons sd-10-002, sd-10-003, sd-10-004: build the Java and research parts from primary documentation and fix the deployment answer
Co-Authored-By: Claude Sonnet 5.5 <noreply@anthropic.com>
Claude-Session: https://claude.ai/code/session_01E4oCkXXqBf2c7oMUzFxEr2
</commit_message>
<xml_diff>
--- a/system-design-101/vi/lessons/sd-10-002/slides/sd-10-002.pptx
+++ b/system-design-101/vi/lessons/sd-10-002/slides/sd-10-002.pptx
@@ -3870,7 +3870,7 @@
               <a:t> dọn</a:t>
             </a:r>
             <a:r>
-              <a:rPr lang="en-US" sz="2550" dirty="0" spc="-2" kern="0">
+              <a:rPr lang="en-US" sz="2550" dirty="0" spc="-3" kern="0">
                 <a:solidFill>
                   <a:srgbClr val="F3EEE3"/>
                 </a:solidFill>
@@ -3878,6 +3878,17 @@
                 <a:ea typeface="Be Vietnam Pro" pitchFamily="34" charset="-122"/>
                 <a:cs typeface="Be Vietnam Pro" pitchFamily="34" charset="-120"/>
               </a:rPr>
+              <a:t> cũ</a:t>
+            </a:r>
+            <a:r>
+              <a:rPr lang="en-US" sz="2550" dirty="0" spc="-1" kern="0">
+                <a:solidFill>
+                  <a:srgbClr val="F3EEE3"/>
+                </a:solidFill>
+                <a:latin typeface="Be Vietnam Pro" pitchFamily="34" charset="0"/>
+                <a:ea typeface="Be Vietnam Pro" pitchFamily="34" charset="-122"/>
+                <a:cs typeface="Be Vietnam Pro" pitchFamily="34" charset="-120"/>
+              </a:rPr>
               <a:t> của</a:t>
             </a:r>
             <a:r>
@@ -3889,7 +3900,62 @@
                 <a:ea typeface="Be Vietnam Pro" pitchFamily="34" charset="-122"/>
                 <a:cs typeface="Be Vietnam Pro" pitchFamily="34" charset="-120"/>
               </a:rPr>
-              <a:t> Java,</a:t>
+              <a:t> Java;</a:t>
+            </a:r>
+            <a:r>
+              <a:rPr lang="en-US" sz="2550" dirty="0" spc="-12" kern="0">
+                <a:solidFill>
+                  <a:srgbClr val="F3EEE3"/>
+                </a:solidFill>
+                <a:latin typeface="Be Vietnam Pro" pitchFamily="34" charset="0"/>
+                <a:ea typeface="Be Vietnam Pro" pitchFamily="34" charset="-122"/>
+                <a:cs typeface="Be Vietnam Pro" pitchFamily="34" charset="-120"/>
+              </a:rPr>
+              <a:t> tài</a:t>
+            </a:r>
+            <a:r>
+              <a:rPr lang="en-US" sz="2550" dirty="0" spc="1" kern="0">
+                <a:solidFill>
+                  <a:srgbClr val="F3EEE3"/>
+                </a:solidFill>
+                <a:latin typeface="Be Vietnam Pro" pitchFamily="34" charset="0"/>
+                <a:ea typeface="Be Vietnam Pro" pitchFamily="34" charset="-122"/>
+                <a:cs typeface="Be Vietnam Pro" pitchFamily="34" charset="-120"/>
+              </a:rPr>
+              <a:t> liệu</a:t>
+            </a:r>
+            <a:r>
+              <a:rPr lang="en-US" sz="2550" dirty="0" spc="-3" kern="0">
+                <a:solidFill>
+                  <a:srgbClr val="F3EEE3"/>
+                </a:solidFill>
+                <a:latin typeface="Be Vietnam Pro" pitchFamily="34" charset="0"/>
+                <a:ea typeface="Be Vietnam Pro" pitchFamily="34" charset="-122"/>
+                <a:cs typeface="Be Vietnam Pro" pitchFamily="34" charset="-120"/>
+              </a:rPr>
+              <a:t> JDK</a:t>
+            </a:r>
+            <a:r>
+              <a:rPr lang="en-US" sz="2550" dirty="0" spc="17" kern="0">
+                <a:solidFill>
+                  <a:srgbClr val="F3EEE3"/>
+                </a:solidFill>
+                <a:latin typeface="Be Vietnam Pro" pitchFamily="34" charset="0"/>
+                <a:ea typeface="Be Vietnam Pro" pitchFamily="34" charset="-122"/>
+                <a:cs typeface="Be Vietnam Pro" pitchFamily="34" charset="-120"/>
+              </a:rPr>
+              <a:t> đã</a:t>
+            </a:r>
+            <a:r>
+              <a:rPr lang="en-US" sz="2550" dirty="0" spc="10" kern="0">
+                <a:solidFill>
+                  <a:srgbClr val="F3EEE3"/>
+                </a:solidFill>
+                <a:latin typeface="Be Vietnam Pro" pitchFamily="34" charset="0"/>
+                <a:ea typeface="Be Vietnam Pro" pitchFamily="34" charset="-122"/>
+                <a:cs typeface="Be Vietnam Pro" pitchFamily="34" charset="-120"/>
+              </a:rPr>
+              <a:t> đọc</a:t>
             </a:r>
             <a:r>
               <a:rPr lang="en-US" sz="2550" dirty="0" spc="0" kern="0">
@@ -3900,10 +3966,10 @@
                 <a:ea typeface="Be Vietnam Pro" pitchFamily="34" charset="-122"/>
                 <a:cs typeface="Be Vietnam Pro" pitchFamily="34" charset="-120"/>
               </a:rPr>
-              <a:t> nhắm</a:t>
-            </a:r>
-            <a:r>
-              <a:rPr lang="en-US" sz="2550" dirty="0" spc="1" kern="0">
+              <a:t> không còn mô</a:t>
+            </a:r>
+            <a:r>
+              <a:rPr lang="en-US" sz="2550" dirty="0" spc="-10" kern="0">
                 <a:solidFill>
                   <a:srgbClr val="F3EEE3"/>
                 </a:solidFill>
@@ -3911,29 +3977,7 @@
                 <a:ea typeface="Be Vietnam Pro" pitchFamily="34" charset="-122"/>
                 <a:cs typeface="Be Vietnam Pro" pitchFamily="34" charset="-120"/>
               </a:rPr>
-              <a:t> giảm</a:t>
-            </a:r>
-            <a:r>
-              <a:rPr lang="en-US" sz="2550" dirty="0" spc="0" kern="0">
-                <a:solidFill>
-                  <a:srgbClr val="F3EEE3"/>
-                </a:solidFill>
-                <a:latin typeface="Be Vietnam Pro" pitchFamily="34" charset="0"/>
-                <a:ea typeface="Be Vietnam Pro" pitchFamily="34" charset="-122"/>
-                <a:cs typeface="Be Vietnam Pro" pitchFamily="34" charset="-120"/>
-              </a:rPr>
-              <a:t> thời gian</a:t>
-            </a:r>
-            <a:r>
-              <a:rPr lang="en-US" sz="2550" dirty="0" spc="17" kern="0">
-                <a:solidFill>
-                  <a:srgbClr val="F3EEE3"/>
-                </a:solidFill>
-                <a:latin typeface="Be Vietnam Pro" pitchFamily="34" charset="0"/>
-                <a:ea typeface="Be Vietnam Pro" pitchFamily="34" charset="-122"/>
-                <a:cs typeface="Be Vietnam Pro" pitchFamily="34" charset="-120"/>
-              </a:rPr>
-              <a:t> dừng.</a:t>
+              <a:t> tả.</a:t>
             </a:r>
             <a:endParaRPr lang="en-US" sz="2550" dirty="0"/>
           </a:p>
@@ -4150,7 +4194,7 @@
               <a:t> dọn</a:t>
             </a:r>
             <a:r>
-              <a:rPr lang="en-US" sz="2550" dirty="0" spc="-2" kern="0">
+              <a:rPr lang="en-US" sz="2550" dirty="0" spc="-23" kern="0">
                 <a:solidFill>
                   <a:srgbClr val="F3EEE3"/>
                 </a:solidFill>
@@ -4158,10 +4202,10 @@
                 <a:ea typeface="Be Vietnam Pro" pitchFamily="34" charset="-122"/>
                 <a:cs typeface="Be Vietnam Pro" pitchFamily="34" charset="-120"/>
               </a:rPr>
-              <a:t> của</a:t>
-            </a:r>
-            <a:r>
-              <a:rPr lang="en-US" sz="2550" dirty="0" spc="-22" kern="0">
+              <a:t> Java</a:t>
+            </a:r>
+            <a:r>
+              <a:rPr lang="en-US" sz="2550" dirty="0" spc="0" kern="0">
                 <a:solidFill>
                   <a:srgbClr val="F3EEE3"/>
                 </a:solidFill>
@@ -4169,7 +4213,40 @@
                 <a:ea typeface="Be Vietnam Pro" pitchFamily="34" charset="-122"/>
                 <a:cs typeface="Be Vietnam Pro" pitchFamily="34" charset="-120"/>
               </a:rPr>
-              <a:t> Java</a:t>
+              <a:t> có thời gian</a:t>
+            </a:r>
+            <a:r>
+              <a:rPr lang="en-US" sz="2550" dirty="0" spc="19" kern="0">
+                <a:solidFill>
+                  <a:srgbClr val="F3EEE3"/>
+                </a:solidFill>
+                <a:latin typeface="Be Vietnam Pro" pitchFamily="34" charset="0"/>
+                <a:ea typeface="Be Vietnam Pro" pitchFamily="34" charset="-122"/>
+                <a:cs typeface="Be Vietnam Pro" pitchFamily="34" charset="-120"/>
+              </a:rPr>
+              <a:t> dừng</a:t>
+            </a:r>
+            <a:r>
+              <a:rPr lang="en-US" sz="2550" dirty="0" spc="0" kern="0">
+                <a:solidFill>
+                  <a:srgbClr val="F3EEE3"/>
+                </a:solidFill>
+                <a:latin typeface="Be Vietnam Pro" pitchFamily="34" charset="0"/>
+                <a:ea typeface="Be Vietnam Pro" pitchFamily="34" charset="-122"/>
+                <a:cs typeface="Be Vietnam Pro" pitchFamily="34" charset="-120"/>
+              </a:rPr>
+              <a:t> cỡ</a:t>
+            </a:r>
+            <a:r>
+              <a:rPr lang="en-US" sz="2550" dirty="0" spc="-14" kern="0">
+                <a:solidFill>
+                  <a:srgbClr val="F3EEE3"/>
+                </a:solidFill>
+                <a:latin typeface="Be Vietnam Pro" pitchFamily="34" charset="0"/>
+                <a:ea typeface="Be Vietnam Pro" pitchFamily="34" charset="-122"/>
+                <a:cs typeface="Be Vietnam Pro" pitchFamily="34" charset="-120"/>
+              </a:rPr>
+              <a:t> vài</a:t>
             </a:r>
             <a:r>
               <a:rPr lang="en-US" sz="2550" dirty="0" spc="-1" kern="0">
@@ -4180,10 +4257,10 @@
                 <a:ea typeface="Be Vietnam Pro" pitchFamily="34" charset="-122"/>
                 <a:cs typeface="Be Vietnam Pro" pitchFamily="34" charset="-120"/>
               </a:rPr>
-              <a:t> cho</a:t>
-            </a:r>
-            <a:r>
-              <a:rPr lang="en-US" sz="2550" dirty="0" spc="-2" kern="0">
+              <a:t> mili</a:t>
+            </a:r>
+            <a:r>
+              <a:rPr lang="en-US" sz="2550" dirty="0" spc="-5" kern="0">
                 <a:solidFill>
                   <a:srgbClr val="F3EEE3"/>
                 </a:solidFill>
@@ -4191,29 +4268,7 @@
                 <a:ea typeface="Be Vietnam Pro" pitchFamily="34" charset="-122"/>
                 <a:cs typeface="Be Vietnam Pro" pitchFamily="34" charset="-120"/>
               </a:rPr>
-              <a:t> vùng</a:t>
-            </a:r>
-            <a:r>
-              <a:rPr lang="en-US" sz="2550" dirty="0" spc="-1" kern="0">
-                <a:solidFill>
-                  <a:srgbClr val="F3EEE3"/>
-                </a:solidFill>
-                <a:latin typeface="Be Vietnam Pro" pitchFamily="34" charset="0"/>
-                <a:ea typeface="Be Vietnam Pro" pitchFamily="34" charset="-122"/>
-                <a:cs typeface="Be Vietnam Pro" pitchFamily="34" charset="-120"/>
-              </a:rPr>
-              <a:t> nhớ</a:t>
-            </a:r>
-            <a:r>
-              <a:rPr lang="en-US" sz="2550" dirty="0" spc="0" kern="0">
-                <a:solidFill>
-                  <a:srgbClr val="F3EEE3"/>
-                </a:solidFill>
-                <a:latin typeface="Be Vietnam Pro" pitchFamily="34" charset="0"/>
-                <a:ea typeface="Be Vietnam Pro" pitchFamily="34" charset="-122"/>
-                <a:cs typeface="Be Vietnam Pro" pitchFamily="34" charset="-120"/>
-              </a:rPr>
-              <a:t> lớn.</a:t>
+              <a:t> giây.</a:t>
             </a:r>
             <a:endParaRPr lang="en-US" sz="2550" dirty="0"/>
           </a:p>
@@ -4305,7 +4360,7 @@
               <a:t>ByteByteGo</a:t>
             </a:r>
             <a:r>
-              <a:rPr lang="en-US" sz="2700" dirty="0" spc="-9" kern="0">
+              <a:rPr lang="en-US" sz="2700" dirty="0" spc="-12" kern="0">
                 <a:solidFill>
                   <a:srgbClr val="F3EEE3"/>
                 </a:solidFill>
@@ -4313,10 +4368,10 @@
                 <a:ea typeface="Be Vietnam Pro" pitchFamily="34" charset="-122"/>
                 <a:cs typeface="Be Vietnam Pro" pitchFamily="34" charset="-120"/>
               </a:rPr>
-              <a:t> system-design-101</a:t>
-            </a:r>
-            <a:r>
-              <a:rPr lang="en-US" sz="2700" dirty="0" spc="2" kern="0">
+              <a:t> (tên</a:t>
+            </a:r>
+            <a:r>
+              <a:rPr lang="en-US" sz="2700" dirty="0" spc="-14" kern="0">
                 <a:solidFill>
                   <a:srgbClr val="F3EEE3"/>
                 </a:solidFill>
@@ -4324,6 +4379,28 @@
                 <a:ea typeface="Be Vietnam Pro" pitchFamily="34" charset="-122"/>
                 <a:cs typeface="Be Vietnam Pro" pitchFamily="34" charset="-120"/>
               </a:rPr>
+              <a:t> ngôn</a:t>
+            </a:r>
+            <a:r>
+              <a:rPr lang="en-US" sz="2700" dirty="0" spc="41" kern="0">
+                <a:solidFill>
+                  <a:srgbClr val="F3EEE3"/>
+                </a:solidFill>
+                <a:latin typeface="Be Vietnam Pro" pitchFamily="34" charset="0"/>
+                <a:ea typeface="Be Vietnam Pro" pitchFamily="34" charset="-122"/>
+                <a:cs typeface="Be Vietnam Pro" pitchFamily="34" charset="-120"/>
+              </a:rPr>
+              <a:t> ngữ)</a:t>
+            </a:r>
+            <a:r>
+              <a:rPr lang="en-US" sz="2700" dirty="0" spc="-3" kern="0">
+                <a:solidFill>
+                  <a:srgbClr val="F3EEE3"/>
+                </a:solidFill>
+                <a:latin typeface="Be Vietnam Pro" pitchFamily="34" charset="0"/>
+                <a:ea typeface="Be Vietnam Pro" pitchFamily="34" charset="-122"/>
+                <a:cs typeface="Be Vietnam Pro" pitchFamily="34" charset="-120"/>
+              </a:rPr>
               <a:t> ·</a:t>
             </a:r>
             <a:r>
@@ -4347,6 +4424,28 @@
                 <a:cs typeface="Be Vietnam Pro" pitchFamily="34" charset="-120"/>
               </a:rPr>
               <a:t> liệu</a:t>
+            </a:r>
+            <a:r>
+              <a:rPr lang="en-US" sz="2700" dirty="0" spc="0" kern="0">
+                <a:solidFill>
+                  <a:srgbClr val="F3EEE3"/>
+                </a:solidFill>
+                <a:latin typeface="Be Vietnam Pro" pitchFamily="34" charset="0"/>
+                <a:ea typeface="Be Vietnam Pro" pitchFamily="34" charset="-122"/>
+                <a:cs typeface="Be Vietnam Pro" pitchFamily="34" charset="-120"/>
+              </a:rPr>
+              <a:t> JDK</a:t>
+            </a:r>
+            <a:r>
+              <a:rPr lang="en-US" sz="2700" dirty="0" spc="-1" kern="0">
+                <a:solidFill>
+                  <a:srgbClr val="F3EEE3"/>
+                </a:solidFill>
+                <a:latin typeface="Be Vietnam Pro" pitchFamily="34" charset="0"/>
+                <a:ea typeface="Be Vietnam Pro" pitchFamily="34" charset="-122"/>
+                <a:cs typeface="Be Vietnam Pro" pitchFamily="34" charset="-120"/>
+              </a:rPr>
+              <a:t> ·</a:t>
             </a:r>
             <a:r>
               <a:rPr lang="en-US" sz="2700" dirty="0" spc="7" kern="0">
@@ -4506,10 +4605,10 @@
                 <a:ea typeface="Be Vietnam Pro" pitchFamily="34" charset="-122"/>
                 <a:cs typeface="Be Vietnam Pro" pitchFamily="34" charset="-120"/>
               </a:rPr>
-              <a:t> 2026-10-18.</a:t>
-            </a:r>
-            <a:r>
-              <a:rPr lang="en-US" sz="1950" dirty="0" spc="0" kern="0">
+              <a:t> 2026-10-19.</a:t>
+            </a:r>
+            <a:r>
+              <a:rPr lang="en-US" sz="1950" dirty="0" spc="1" kern="0">
                 <a:solidFill>
                   <a:srgbClr val="9AA0B5"/>
                 </a:solidFill>
@@ -4531,7 +4630,7 @@
               <a:t> minh</a:t>
             </a:r>
             <a:r>
-              <a:rPr lang="en-US" sz="1950" dirty="0" spc="-3" kern="0">
+              <a:rPr lang="en-US" sz="1950" dirty="0" spc="-4" kern="0">
                 <a:solidFill>
                   <a:srgbClr val="9AA0B5"/>
                 </a:solidFill>
@@ -8912,18 +9011,18 @@
               <a:t> bản</a:t>
             </a:r>
             <a:r>
-              <a:rPr lang="en-US" sz="2550" dirty="0" spc="-23" kern="0">
-                <a:solidFill>
-                  <a:srgbClr val="14161C"/>
-                </a:solidFill>
-                <a:latin typeface="Be Vietnam Pro" pitchFamily="34" charset="0"/>
-                <a:ea typeface="Be Vietnam Pro" pitchFamily="34" charset="-122"/>
-                <a:cs typeface="Be Vietnam Pro" pitchFamily="34" charset="-120"/>
-              </a:rPr>
-              <a:t> Java</a:t>
-            </a:r>
-            <a:r>
-              <a:rPr lang="en-US" sz="2550" dirty="0" spc="11" kern="0">
+              <a:rPr lang="en-US" sz="2550" dirty="0" spc="-4" kern="0">
+                <a:solidFill>
+                  <a:srgbClr val="14161C"/>
+                </a:solidFill>
+                <a:latin typeface="Be Vietnam Pro" pitchFamily="34" charset="0"/>
+                <a:ea typeface="Be Vietnam Pro" pitchFamily="34" charset="-122"/>
+                <a:cs typeface="Be Vietnam Pro" pitchFamily="34" charset="-120"/>
+              </a:rPr>
+              <a:t> JDK</a:t>
+            </a:r>
+            <a:r>
+              <a:rPr lang="en-US" sz="2550" dirty="0" spc="10" kern="0">
                 <a:solidFill>
                   <a:srgbClr val="14161C"/>
                 </a:solidFill>
@@ -8934,7 +9033,7 @@
               <a:t> đang</a:t>
             </a:r>
             <a:r>
-              <a:rPr lang="en-US" sz="2550" dirty="0" spc="-1" kern="0">
+              <a:rPr lang="en-US" sz="2550" dirty="0" spc="0" kern="0">
                 <a:solidFill>
                   <a:srgbClr val="14161C"/>
                 </a:solidFill>
@@ -9129,40 +9228,29 @@
               <a:buNone/>
             </a:pPr>
             <a:r>
-              <a:rPr lang="en-US" sz="2250" dirty="0" spc="-8" kern="0">
-                <a:solidFill>
-                  <a:srgbClr val="14161C"/>
-                </a:solidFill>
-                <a:latin typeface="Be Vietnam Pro" pitchFamily="34" charset="0"/>
-                <a:ea typeface="Be Vietnam Pro" pitchFamily="34" charset="-122"/>
-                <a:cs typeface="Be Vietnam Pro" pitchFamily="34" charset="-120"/>
-              </a:rPr>
-              <a:t>Một</a:t>
-            </a:r>
-            <a:r>
-              <a:rPr lang="en-US" sz="2250" dirty="0" spc="1" kern="0">
-                <a:solidFill>
-                  <a:srgbClr val="14161C"/>
-                </a:solidFill>
-                <a:latin typeface="Be Vietnam Pro" pitchFamily="34" charset="0"/>
-                <a:ea typeface="Be Vietnam Pro" pitchFamily="34" charset="-122"/>
-                <a:cs typeface="Be Vietnam Pro" pitchFamily="34" charset="-120"/>
-              </a:rPr>
-              <a:t> luồng</a:t>
-            </a:r>
-            <a:r>
-              <a:rPr lang="en-US" sz="2250" dirty="0" spc="-3" kern="0">
-                <a:solidFill>
-                  <a:srgbClr val="14161C"/>
-                </a:solidFill>
-                <a:latin typeface="Be Vietnam Pro" pitchFamily="34" charset="0"/>
-                <a:ea typeface="Be Vietnam Pro" pitchFamily="34" charset="-122"/>
-                <a:cs typeface="Be Vietnam Pro" pitchFamily="34" charset="-120"/>
-              </a:rPr>
-              <a:t> hoặc</a:t>
-            </a:r>
-            <a:r>
-              <a:rPr lang="en-US" sz="2250" dirty="0" spc="25" kern="0">
+              <a:rPr lang="en-US" sz="2250" dirty="0" spc="5" kern="0">
+                <a:solidFill>
+                  <a:srgbClr val="14161C"/>
+                </a:solidFill>
+                <a:latin typeface="Be Vietnam Pro" pitchFamily="34" charset="0"/>
+                <a:ea typeface="Be Vietnam Pro" pitchFamily="34" charset="-122"/>
+                <a:cs typeface="Be Vietnam Pro" pitchFamily="34" charset="-120"/>
+              </a:rPr>
+              <a:t>Thường</a:t>
+            </a:r>
+            <a:r>
+              <a:rPr lang="en-US" sz="2250" dirty="0" spc="4" kern="0">
+                <a:solidFill>
+                  <a:srgbClr val="14161C"/>
+                </a:solidFill>
+                <a:latin typeface="Be Vietnam Pro" pitchFamily="34" charset="0"/>
+                <a:ea typeface="Be Vietnam Pro" pitchFamily="34" charset="-122"/>
+                <a:cs typeface="Be Vietnam Pro" pitchFamily="34" charset="-120"/>
+              </a:rPr>
+              <a:t> hợp</a:t>
+            </a:r>
+            <a:r>
+              <a:rPr lang="en-US" sz="2250" dirty="0" spc="24" kern="0">
                 <a:solidFill>
                   <a:srgbClr val="14161C"/>
                 </a:solidFill>
@@ -9173,6 +9261,17 @@
               <a:t> ứng</a:t>
             </a:r>
             <a:r>
+              <a:rPr lang="en-US" sz="2250" dirty="0" spc="3" kern="0">
+                <a:solidFill>
+                  <a:srgbClr val="14161C"/>
+                </a:solidFill>
+                <a:latin typeface="Be Vietnam Pro" pitchFamily="34" charset="0"/>
+                <a:ea typeface="Be Vietnam Pro" pitchFamily="34" charset="-122"/>
+                <a:cs typeface="Be Vietnam Pro" pitchFamily="34" charset="-120"/>
+              </a:rPr>
+              <a:t> dụng</a:t>
+            </a:r>
+            <a:r>
               <a:rPr lang="en-US" sz="2250" dirty="0" spc="2" kern="0">
                 <a:solidFill>
                   <a:srgbClr val="14161C"/>
@@ -9181,18 +9280,40 @@
                 <a:ea typeface="Be Vietnam Pro" pitchFamily="34" charset="-122"/>
                 <a:cs typeface="Be Vietnam Pro" pitchFamily="34" charset="-120"/>
               </a:rPr>
-              <a:t> dụng</a:t>
-            </a:r>
-            <a:r>
-              <a:rPr lang="en-US" sz="2250" dirty="0" spc="4" kern="0">
-                <a:solidFill>
-                  <a:srgbClr val="14161C"/>
-                </a:solidFill>
-                <a:latin typeface="Be Vietnam Pro" pitchFamily="34" charset="0"/>
-                <a:ea typeface="Be Vietnam Pro" pitchFamily="34" charset="-122"/>
-                <a:cs typeface="Be Vietnam Pro" pitchFamily="34" charset="-120"/>
-              </a:rPr>
-              <a:t> nhỏ.</a:t>
+              <a:t> nhỏ</a:t>
+            </a:r>
+            <a:r>
+              <a:rPr lang="en-US" sz="2250" dirty="0" spc="-16" kern="0">
+                <a:solidFill>
+                  <a:srgbClr val="14161C"/>
+                </a:solidFill>
+                <a:latin typeface="Be Vietnam Pro" pitchFamily="34" charset="0"/>
+                <a:ea typeface="Be Vietnam Pro" pitchFamily="34" charset="-122"/>
+                <a:cs typeface="Be Vietnam Pro" pitchFamily="34" charset="-120"/>
+              </a:rPr>
+              <a:t> và</a:t>
+            </a:r>
+            <a:r>
+              <a:rPr lang="en-US" sz="2250" dirty="0" spc="12" kern="0">
+                <a:solidFill>
+                  <a:srgbClr val="14161C"/>
+                </a:solidFill>
+                <a:latin typeface="Be Vietnam Pro" pitchFamily="34" charset="0"/>
+                <a:ea typeface="Be Vietnam Pro" pitchFamily="34" charset="-122"/>
+                <a:cs typeface="Be Vietnam Pro" pitchFamily="34" charset="-120"/>
+              </a:rPr>
+              <a:t> đơn</a:t>
+            </a:r>
+            <a:r>
+              <a:rPr lang="en-US" sz="2250" dirty="0" spc="0" kern="0">
+                <a:solidFill>
+                  <a:srgbClr val="14161C"/>
+                </a:solidFill>
+                <a:latin typeface="Be Vietnam Pro" pitchFamily="34" charset="0"/>
+                <a:ea typeface="Be Vietnam Pro" pitchFamily="34" charset="-122"/>
+                <a:cs typeface="Be Vietnam Pro" pitchFamily="34" charset="-120"/>
+              </a:rPr>
+              <a:t> giản.</a:t>
             </a:r>
             <a:endParaRPr lang="en-US" sz="2250" dirty="0"/>
           </a:p>
@@ -9269,37 +9390,59 @@
               <a:buNone/>
             </a:pPr>
             <a:r>
-              <a:rPr lang="en-US" sz="2250" dirty="0" spc="-10" kern="0">
-                <a:solidFill>
-                  <a:srgbClr val="14161C"/>
-                </a:solidFill>
-                <a:latin typeface="Be Vietnam Pro" pitchFamily="34" charset="0"/>
-                <a:ea typeface="Be Vietnam Pro" pitchFamily="34" charset="-122"/>
-                <a:cs typeface="Be Vietnam Pro" pitchFamily="34" charset="-120"/>
-              </a:rPr>
-              <a:t>Throughput</a:t>
-            </a:r>
-            <a:r>
-              <a:rPr lang="en-US" sz="2250" dirty="0" spc="-7" kern="0">
-                <a:solidFill>
-                  <a:srgbClr val="14161C"/>
-                </a:solidFill>
-                <a:latin typeface="Be Vietnam Pro" pitchFamily="34" charset="0"/>
-                <a:ea typeface="Be Vietnam Pro" pitchFamily="34" charset="-122"/>
-                <a:cs typeface="Be Vietnam Pro" pitchFamily="34" charset="-120"/>
-              </a:rPr>
-              <a:t> Collector:</a:t>
-            </a:r>
-            <a:r>
-              <a:rPr lang="en-US" sz="2250" dirty="0" spc="17" kern="0">
-                <a:solidFill>
-                  <a:srgbClr val="14161C"/>
-                </a:solidFill>
-                <a:latin typeface="Be Vietnam Pro" pitchFamily="34" charset="0"/>
-                <a:ea typeface="Be Vietnam Pro" pitchFamily="34" charset="-122"/>
-                <a:cs typeface="Be Vietnam Pro" pitchFamily="34" charset="-120"/>
-              </a:rPr>
-              <a:t> đề</a:t>
+              <a:rPr lang="en-US" sz="2250" dirty="0" spc="-3" kern="0">
+                <a:solidFill>
+                  <a:srgbClr val="14161C"/>
+                </a:solidFill>
+                <a:latin typeface="Be Vietnam Pro" pitchFamily="34" charset="0"/>
+                <a:ea typeface="Be Vietnam Pro" pitchFamily="34" charset="-122"/>
+                <a:cs typeface="Be Vietnam Pro" pitchFamily="34" charset="-120"/>
+              </a:rPr>
+              <a:t>Nhiều</a:t>
+            </a:r>
+            <a:r>
+              <a:rPr lang="en-US" sz="2250" dirty="0" spc="1" kern="0">
+                <a:solidFill>
+                  <a:srgbClr val="14161C"/>
+                </a:solidFill>
+                <a:latin typeface="Be Vietnam Pro" pitchFamily="34" charset="0"/>
+                <a:ea typeface="Be Vietnam Pro" pitchFamily="34" charset="-122"/>
+                <a:cs typeface="Be Vietnam Pro" pitchFamily="34" charset="-120"/>
+              </a:rPr>
+              <a:t> bộ xử</a:t>
+            </a:r>
+            <a:r>
+              <a:rPr lang="en-US" sz="2250" dirty="0" spc="-1" kern="0">
+                <a:solidFill>
+                  <a:srgbClr val="14161C"/>
+                </a:solidFill>
+                <a:latin typeface="Be Vietnam Pro" pitchFamily="34" charset="0"/>
+                <a:ea typeface="Be Vietnam Pro" pitchFamily="34" charset="-122"/>
+                <a:cs typeface="Be Vietnam Pro" pitchFamily="34" charset="-120"/>
+              </a:rPr>
+              <a:t> lý;</a:t>
+            </a:r>
+            <a:r>
+              <a:rPr lang="en-US" sz="2250" dirty="0" spc="4" kern="0">
+                <a:solidFill>
+                  <a:srgbClr val="14161C"/>
+                </a:solidFill>
+                <a:latin typeface="Be Vietnam Pro" pitchFamily="34" charset="0"/>
+                <a:ea typeface="Be Vietnam Pro" pitchFamily="34" charset="-122"/>
+                <a:cs typeface="Be Vietnam Pro" pitchFamily="34" charset="-120"/>
+              </a:rPr>
+              <a:t> còn</a:t>
+            </a:r>
+            <a:r>
+              <a:rPr lang="en-US" sz="2250" dirty="0" spc="-11" kern="0">
+                <a:solidFill>
+                  <a:srgbClr val="14161C"/>
+                </a:solidFill>
+                <a:latin typeface="Be Vietnam Pro" pitchFamily="34" charset="0"/>
+                <a:ea typeface="Be Vietnam Pro" pitchFamily="34" charset="-122"/>
+                <a:cs typeface="Be Vietnam Pro" pitchFamily="34" charset="-120"/>
+              </a:rPr>
+              <a:t> gọi</a:t>
             </a:r>
             <a:r>
               <a:rPr lang="en-US" sz="2250" dirty="0" spc="0" kern="0">
@@ -9310,7 +9453,18 @@
                 <a:ea typeface="Be Vietnam Pro" pitchFamily="34" charset="-122"/>
                 <a:cs typeface="Be Vietnam Pro" pitchFamily="34" charset="-120"/>
               </a:rPr>
-              <a:t> cao</a:t>
+              <a:t> là bộ</a:t>
+            </a:r>
+            <a:r>
+              <a:rPr lang="en-US" sz="2250" dirty="0" spc="4" kern="0">
+                <a:solidFill>
+                  <a:srgbClr val="14161C"/>
+                </a:solidFill>
+                <a:latin typeface="Be Vietnam Pro" pitchFamily="34" charset="0"/>
+                <a:ea typeface="Be Vietnam Pro" pitchFamily="34" charset="-122"/>
+                <a:cs typeface="Be Vietnam Pro" pitchFamily="34" charset="-120"/>
+              </a:rPr>
+              <a:t> dọn</a:t>
             </a:r>
             <a:r>
               <a:rPr lang="en-US" sz="2250" dirty="0" spc="1" kern="0">
@@ -9367,7 +9521,7 @@
               <a:buNone/>
             </a:pPr>
             <a:r>
-              <a:rPr lang="en-US" sz="2250" b="1" dirty="0" spc="1" kern="0">
+              <a:rPr lang="en-US" sz="2250" b="1" dirty="0" spc="-1" kern="0">
                 <a:solidFill>
                   <a:srgbClr val="F3EEE3"/>
                 </a:solidFill>
@@ -9375,7 +9529,7 @@
                 <a:ea typeface="Be Vietnam Pro" pitchFamily="34" charset="-122"/>
                 <a:cs typeface="Be Vietnam Pro" pitchFamily="34" charset="-120"/>
               </a:rPr>
-              <a:t>CMS</a:t>
+              <a:t>G1</a:t>
             </a:r>
             <a:endParaRPr lang="en-US" sz="2250" dirty="0"/>
           </a:p>
@@ -9417,18 +9571,29 @@
                 <a:ea typeface="Be Vietnam Pro" pitchFamily="34" charset="-122"/>
                 <a:cs typeface="Be Vietnam Pro" pitchFamily="34" charset="-120"/>
               </a:rPr>
-              <a:t>Độ</a:t>
-            </a:r>
-            <a:r>
-              <a:rPr lang="en-US" sz="2250" dirty="0" spc="-24" kern="0">
-                <a:solidFill>
-                  <a:srgbClr val="14161C"/>
-                </a:solidFill>
-                <a:latin typeface="Be Vietnam Pro" pitchFamily="34" charset="0"/>
-                <a:ea typeface="Be Vietnam Pro" pitchFamily="34" charset="-122"/>
-                <a:cs typeface="Be Vietnam Pro" pitchFamily="34" charset="-120"/>
-              </a:rPr>
-              <a:t> trễ</a:t>
+              <a:t>Hợp vùng</a:t>
+            </a:r>
+            <a:r>
+              <a:rPr lang="en-US" sz="2250" dirty="0" spc="3" kern="0">
+                <a:solidFill>
+                  <a:srgbClr val="14161C"/>
+                </a:solidFill>
+                <a:latin typeface="Be Vietnam Pro" pitchFamily="34" charset="0"/>
+                <a:ea typeface="Be Vietnam Pro" pitchFamily="34" charset="-122"/>
+                <a:cs typeface="Be Vietnam Pro" pitchFamily="34" charset="-120"/>
+              </a:rPr>
+              <a:t> nhớ</a:t>
+            </a:r>
+            <a:r>
+              <a:rPr lang="en-US" sz="2250" dirty="0" spc="1" kern="0">
+                <a:solidFill>
+                  <a:srgbClr val="14161C"/>
+                </a:solidFill>
+                <a:latin typeface="Be Vietnam Pro" pitchFamily="34" charset="0"/>
+                <a:ea typeface="Be Vietnam Pro" pitchFamily="34" charset="-122"/>
+                <a:cs typeface="Be Vietnam Pro" pitchFamily="34" charset="-120"/>
+              </a:rPr>
+              <a:t> lớn;</a:t>
             </a:r>
             <a:r>
               <a:rPr lang="en-US" sz="2250" dirty="0" spc="0" kern="0">
@@ -9439,29 +9604,40 @@
                 <a:ea typeface="Be Vietnam Pro" pitchFamily="34" charset="-122"/>
                 <a:cs typeface="Be Vietnam Pro" pitchFamily="34" charset="-120"/>
               </a:rPr>
-              <a:t> thấp,</a:t>
-            </a:r>
-            <a:r>
-              <a:rPr lang="en-US" sz="2250" dirty="0" spc="-3" kern="0">
-                <a:solidFill>
-                  <a:srgbClr val="14161C"/>
-                </a:solidFill>
-                <a:latin typeface="Be Vietnam Pro" pitchFamily="34" charset="0"/>
-                <a:ea typeface="Be Vietnam Pro" pitchFamily="34" charset="-122"/>
-                <a:cs typeface="Be Vietnam Pro" pitchFamily="34" charset="-120"/>
-              </a:rPr>
-              <a:t> giảm</a:t>
-            </a:r>
-            <a:r>
-              <a:rPr lang="en-US" sz="2250" dirty="0" spc="1" kern="0">
-                <a:solidFill>
-                  <a:srgbClr val="14161C"/>
-                </a:solidFill>
-                <a:latin typeface="Be Vietnam Pro" pitchFamily="34" charset="0"/>
-                <a:ea typeface="Be Vietnam Pro" pitchFamily="34" charset="-122"/>
-                <a:cs typeface="Be Vietnam Pro" pitchFamily="34" charset="-120"/>
-              </a:rPr>
-              <a:t> thời</a:t>
+              <a:t> mặc</a:t>
+            </a:r>
+            <a:r>
+              <a:rPr lang="en-US" sz="2250" dirty="0" spc="18" kern="0">
+                <a:solidFill>
+                  <a:srgbClr val="14161C"/>
+                </a:solidFill>
+                <a:latin typeface="Be Vietnam Pro" pitchFamily="34" charset="0"/>
+                <a:ea typeface="Be Vietnam Pro" pitchFamily="34" charset="-122"/>
+                <a:cs typeface="Be Vietnam Pro" pitchFamily="34" charset="-120"/>
+              </a:rPr>
+              <a:t> định</a:t>
+            </a:r>
+            <a:r>
+              <a:rPr lang="en-US" sz="2250" dirty="0" spc="-16" kern="0">
+                <a:solidFill>
+                  <a:srgbClr val="14161C"/>
+                </a:solidFill>
+                <a:latin typeface="Be Vietnam Pro" pitchFamily="34" charset="0"/>
+                <a:ea typeface="Be Vietnam Pro" pitchFamily="34" charset="-122"/>
+                <a:cs typeface="Be Vietnam Pro" pitchFamily="34" charset="-120"/>
+              </a:rPr>
+              <a:t> trong</a:t>
+            </a:r>
+            <a:r>
+              <a:rPr lang="en-US" sz="2250" dirty="0" spc="-12" kern="0">
+                <a:solidFill>
+                  <a:srgbClr val="14161C"/>
+                </a:solidFill>
+                <a:latin typeface="Be Vietnam Pro" pitchFamily="34" charset="0"/>
+                <a:ea typeface="Be Vietnam Pro" pitchFamily="34" charset="-122"/>
+                <a:cs typeface="Be Vietnam Pro" pitchFamily="34" charset="-120"/>
+              </a:rPr>
+              <a:t> tài</a:t>
             </a:r>
             <a:r>
               <a:rPr lang="en-US" sz="2250" dirty="0" spc="-2" kern="0">
@@ -9472,18 +9648,29 @@
                 <a:ea typeface="Be Vietnam Pro" pitchFamily="34" charset="-122"/>
                 <a:cs typeface="Be Vietnam Pro" pitchFamily="34" charset="-120"/>
               </a:rPr>
-              <a:t> gian</a:t>
-            </a:r>
-            <a:r>
-              <a:rPr lang="en-US" sz="2250" dirty="0" spc="18" kern="0">
-                <a:solidFill>
-                  <a:srgbClr val="14161C"/>
-                </a:solidFill>
-                <a:latin typeface="Be Vietnam Pro" pitchFamily="34" charset="0"/>
-                <a:ea typeface="Be Vietnam Pro" pitchFamily="34" charset="-122"/>
-                <a:cs typeface="Be Vietnam Pro" pitchFamily="34" charset="-120"/>
-              </a:rPr>
-              <a:t> dừng.</a:t>
+              <a:t> liệu</a:t>
+            </a:r>
+            <a:r>
+              <a:rPr lang="en-US" sz="2250" dirty="0" spc="15" kern="0">
+                <a:solidFill>
+                  <a:srgbClr val="14161C"/>
+                </a:solidFill>
+                <a:latin typeface="Be Vietnam Pro" pitchFamily="34" charset="0"/>
+                <a:ea typeface="Be Vietnam Pro" pitchFamily="34" charset="-122"/>
+                <a:cs typeface="Be Vietnam Pro" pitchFamily="34" charset="-120"/>
+              </a:rPr>
+              <a:t> đã</a:t>
+            </a:r>
+            <a:r>
+              <a:rPr lang="en-US" sz="2250" dirty="0" spc="11" kern="0">
+                <a:solidFill>
+                  <a:srgbClr val="14161C"/>
+                </a:solidFill>
+                <a:latin typeface="Be Vietnam Pro" pitchFamily="34" charset="0"/>
+                <a:ea typeface="Be Vietnam Pro" pitchFamily="34" charset="-122"/>
+                <a:cs typeface="Be Vietnam Pro" pitchFamily="34" charset="-120"/>
+              </a:rPr>
+              <a:t> đọc.</a:t>
             </a:r>
             <a:endParaRPr lang="en-US" sz="2250" dirty="0"/>
           </a:p>
@@ -9518,7 +9705,7 @@
               <a:buNone/>
             </a:pPr>
             <a:r>
-              <a:rPr lang="en-US" sz="2250" b="1" dirty="0" spc="-1" kern="0">
+              <a:rPr lang="en-US" sz="2250" b="1" dirty="0" spc="3" kern="0">
                 <a:solidFill>
                   <a:srgbClr val="F3EEE3"/>
                 </a:solidFill>
@@ -9526,7 +9713,7 @@
                 <a:ea typeface="Be Vietnam Pro" pitchFamily="34" charset="-122"/>
                 <a:cs typeface="Be Vietnam Pro" pitchFamily="34" charset="-120"/>
               </a:rPr>
-              <a:t>G1</a:t>
+              <a:t>ZGC</a:t>
             </a:r>
             <a:endParaRPr lang="en-US" sz="2250" dirty="0"/>
           </a:p>
@@ -9560,6 +9747,83 @@
               <a:buNone/>
             </a:pPr>
             <a:r>
+              <a:rPr lang="en-US" sz="2250" dirty="0" spc="-1" kern="0">
+                <a:solidFill>
+                  <a:srgbClr val="14161C"/>
+                </a:solidFill>
+                <a:latin typeface="Be Vietnam Pro" pitchFamily="34" charset="0"/>
+                <a:ea typeface="Be Vietnam Pro" pitchFamily="34" charset="-122"/>
+                <a:cs typeface="Be Vietnam Pro" pitchFamily="34" charset="-120"/>
+              </a:rPr>
+              <a:t>Thời gian</a:t>
+            </a:r>
+            <a:r>
+              <a:rPr lang="en-US" sz="2250" dirty="0" spc="20" kern="0">
+                <a:solidFill>
+                  <a:srgbClr val="14161C"/>
+                </a:solidFill>
+                <a:latin typeface="Be Vietnam Pro" pitchFamily="34" charset="0"/>
+                <a:ea typeface="Be Vietnam Pro" pitchFamily="34" charset="-122"/>
+                <a:cs typeface="Be Vietnam Pro" pitchFamily="34" charset="-120"/>
+              </a:rPr>
+              <a:t> dừng</a:t>
+            </a:r>
+            <a:r>
+              <a:rPr lang="en-US" sz="2250" dirty="0" spc="5" kern="0">
+                <a:solidFill>
+                  <a:srgbClr val="14161C"/>
+                </a:solidFill>
+                <a:latin typeface="Be Vietnam Pro" pitchFamily="34" charset="0"/>
+                <a:ea typeface="Be Vietnam Pro" pitchFamily="34" charset="-122"/>
+                <a:cs typeface="Be Vietnam Pro" pitchFamily="34" charset="-120"/>
+              </a:rPr>
+              <a:t> cỡ</a:t>
+            </a:r>
+            <a:r>
+              <a:rPr lang="en-US" sz="2250" dirty="0" spc="-2" kern="0">
+                <a:solidFill>
+                  <a:srgbClr val="14161C"/>
+                </a:solidFill>
+                <a:latin typeface="Be Vietnam Pro" pitchFamily="34" charset="0"/>
+                <a:ea typeface="Be Vietnam Pro" pitchFamily="34" charset="-122"/>
+                <a:cs typeface="Be Vietnam Pro" pitchFamily="34" charset="-120"/>
+              </a:rPr>
+              <a:t> mili</a:t>
+            </a:r>
+            <a:r>
+              <a:rPr lang="en-US" sz="2250" dirty="0" spc="-9" kern="0">
+                <a:solidFill>
+                  <a:srgbClr val="14161C"/>
+                </a:solidFill>
+                <a:latin typeface="Be Vietnam Pro" pitchFamily="34" charset="0"/>
+                <a:ea typeface="Be Vietnam Pro" pitchFamily="34" charset="-122"/>
+                <a:cs typeface="Be Vietnam Pro" pitchFamily="34" charset="-120"/>
+              </a:rPr>
+              <a:t> giây,</a:t>
+            </a:r>
+            <a:r>
+              <a:rPr lang="en-US" sz="2250" dirty="0" spc="1" kern="0">
+                <a:solidFill>
+                  <a:srgbClr val="14161C"/>
+                </a:solidFill>
+                <a:latin typeface="Be Vietnam Pro" pitchFamily="34" charset="0"/>
+                <a:ea typeface="Be Vietnam Pro" pitchFamily="34" charset="-122"/>
+                <a:cs typeface="Be Vietnam Pro" pitchFamily="34" charset="-120"/>
+              </a:rPr>
+              <a:t> không</a:t>
+            </a:r>
+            <a:r>
+              <a:rPr lang="en-US" sz="2250" dirty="0" spc="-9" kern="0">
+                <a:solidFill>
+                  <a:srgbClr val="14161C"/>
+                </a:solidFill>
+                <a:latin typeface="Be Vietnam Pro" pitchFamily="34" charset="0"/>
+                <a:ea typeface="Be Vietnam Pro" pitchFamily="34" charset="-122"/>
+                <a:cs typeface="Be Vietnam Pro" pitchFamily="34" charset="-120"/>
+              </a:rPr>
+              <a:t> tăng</a:t>
+            </a:r>
+            <a:r>
               <a:rPr lang="en-US" sz="2250" dirty="0" spc="-3" kern="0">
                 <a:solidFill>
                   <a:srgbClr val="14161C"/>
@@ -9568,18 +9832,7 @@
                 <a:ea typeface="Be Vietnam Pro" pitchFamily="34" charset="-122"/>
                 <a:cs typeface="Be Vietnam Pro" pitchFamily="34" charset="-120"/>
               </a:rPr>
-              <a:t>Cân</a:t>
-            </a:r>
-            <a:r>
-              <a:rPr lang="en-US" sz="2250" dirty="0" spc="-2" kern="0">
-                <a:solidFill>
-                  <a:srgbClr val="14161C"/>
-                </a:solidFill>
-                <a:latin typeface="Be Vietnam Pro" pitchFamily="34" charset="0"/>
-                <a:ea typeface="Be Vietnam Pro" pitchFamily="34" charset="-122"/>
-                <a:cs typeface="Be Vietnam Pro" pitchFamily="34" charset="-120"/>
-              </a:rPr>
-              <a:t> bằng</a:t>
+              <a:t> theo</a:t>
             </a:r>
             <a:r>
               <a:rPr lang="en-US" sz="2250" dirty="0" spc="1" kern="0">
@@ -9590,51 +9843,18 @@
                 <a:ea typeface="Be Vietnam Pro" pitchFamily="34" charset="-122"/>
                 <a:cs typeface="Be Vietnam Pro" pitchFamily="34" charset="-120"/>
               </a:rPr>
-              <a:t> thông</a:t>
-            </a:r>
-            <a:r>
-              <a:rPr lang="en-US" sz="2250" dirty="0" spc="6" kern="0">
-                <a:solidFill>
-                  <a:srgbClr val="14161C"/>
-                </a:solidFill>
-                <a:latin typeface="Be Vietnam Pro" pitchFamily="34" charset="0"/>
-                <a:ea typeface="Be Vietnam Pro" pitchFamily="34" charset="-122"/>
-                <a:cs typeface="Be Vietnam Pro" pitchFamily="34" charset="-120"/>
-              </a:rPr>
-              <a:t> lượng</a:t>
-            </a:r>
-            <a:r>
-              <a:rPr lang="en-US" sz="2250" dirty="0" spc="-16" kern="0">
-                <a:solidFill>
-                  <a:srgbClr val="14161C"/>
-                </a:solidFill>
-                <a:latin typeface="Be Vietnam Pro" pitchFamily="34" charset="0"/>
-                <a:ea typeface="Be Vietnam Pro" pitchFamily="34" charset="-122"/>
-                <a:cs typeface="Be Vietnam Pro" pitchFamily="34" charset="-120"/>
-              </a:rPr>
-              <a:t> và</a:t>
-            </a:r>
-            <a:r>
-              <a:rPr lang="en-US" sz="2250" dirty="0" spc="19" kern="0">
-                <a:solidFill>
-                  <a:srgbClr val="14161C"/>
-                </a:solidFill>
-                <a:latin typeface="Be Vietnam Pro" pitchFamily="34" charset="0"/>
-                <a:ea typeface="Be Vietnam Pro" pitchFamily="34" charset="-122"/>
-                <a:cs typeface="Be Vietnam Pro" pitchFamily="34" charset="-120"/>
-              </a:rPr>
-              <a:t> độ</a:t>
-            </a:r>
-            <a:r>
-              <a:rPr lang="en-US" sz="2250" dirty="0" spc="-18" kern="0">
-                <a:solidFill>
-                  <a:srgbClr val="14161C"/>
-                </a:solidFill>
-                <a:latin typeface="Be Vietnam Pro" pitchFamily="34" charset="0"/>
-                <a:ea typeface="Be Vietnam Pro" pitchFamily="34" charset="-122"/>
-                <a:cs typeface="Be Vietnam Pro" pitchFamily="34" charset="-120"/>
-              </a:rPr>
-              <a:t> trễ.</a:t>
+              <a:t> vùng</a:t>
+            </a:r>
+            <a:r>
+              <a:rPr lang="en-US" sz="2250" dirty="0" spc="3" kern="0">
+                <a:solidFill>
+                  <a:srgbClr val="14161C"/>
+                </a:solidFill>
+                <a:latin typeface="Be Vietnam Pro" pitchFamily="34" charset="0"/>
+                <a:ea typeface="Be Vietnam Pro" pitchFamily="34" charset="-122"/>
+                <a:cs typeface="Be Vietnam Pro" pitchFamily="34" charset="-120"/>
+              </a:rPr>
+              <a:t> nhớ.</a:t>
             </a:r>
             <a:endParaRPr lang="en-US" sz="2250" dirty="0"/>
           </a:p>
@@ -9669,7 +9889,7 @@
               <a:buNone/>
             </a:pPr>
             <a:r>
-              <a:rPr lang="en-US" sz="2250" b="1" dirty="0" spc="3" kern="0">
+              <a:rPr lang="en-US" sz="1650" b="1" dirty="0" spc="-5" kern="0">
                 <a:solidFill>
                   <a:srgbClr val="F3EEE3"/>
                 </a:solidFill>
@@ -9677,9 +9897,9 @@
                 <a:ea typeface="Be Vietnam Pro" pitchFamily="34" charset="-122"/>
                 <a:cs typeface="Be Vietnam Pro" pitchFamily="34" charset="-120"/>
               </a:rPr>
-              <a:t>ZGC</a:t>
-            </a:r>
-            <a:endParaRPr lang="en-US" sz="2250" dirty="0"/>
+              <a:t>Shenandoah</a:t>
+            </a:r>
+            <a:endParaRPr lang="en-US" sz="1650" dirty="0"/>
           </a:p>
         </p:txBody>
       </p:sp>
@@ -9711,15 +9931,37 @@
               <a:buNone/>
             </a:pPr>
             <a:r>
-              <a:rPr lang="en-US" sz="2250" dirty="0" spc="-21" kern="0">
-                <a:solidFill>
-                  <a:srgbClr val="14161C"/>
-                </a:solidFill>
-                <a:latin typeface="Be Vietnam Pro" pitchFamily="34" charset="0"/>
-                <a:ea typeface="Be Vietnam Pro" pitchFamily="34" charset="-122"/>
-                <a:cs typeface="Be Vietnam Pro" pitchFamily="34" charset="-120"/>
-              </a:rPr>
-              <a:t>Vùng</a:t>
+              <a:rPr lang="en-US" sz="2250" dirty="0" spc="0" kern="0">
+                <a:solidFill>
+                  <a:srgbClr val="14161C"/>
+                </a:solidFill>
+                <a:latin typeface="Be Vietnam Pro" pitchFamily="34" charset="0"/>
+                <a:ea typeface="Be Vietnam Pro" pitchFamily="34" charset="-122"/>
+                <a:cs typeface="Be Vietnam Pro" pitchFamily="34" charset="-120"/>
+              </a:rPr>
+              <a:t>Đồng thời, thời</a:t>
+            </a:r>
+            <a:r>
+              <a:rPr lang="en-US" sz="2250" dirty="0" spc="-1" kern="0">
+                <a:solidFill>
+                  <a:srgbClr val="14161C"/>
+                </a:solidFill>
+                <a:latin typeface="Be Vietnam Pro" pitchFamily="34" charset="0"/>
+                <a:ea typeface="Be Vietnam Pro" pitchFamily="34" charset="-122"/>
+                <a:cs typeface="Be Vietnam Pro" pitchFamily="34" charset="-120"/>
+              </a:rPr>
+              <a:t> gian</a:t>
+            </a:r>
+            <a:r>
+              <a:rPr lang="en-US" sz="2250" dirty="0" spc="20" kern="0">
+                <a:solidFill>
+                  <a:srgbClr val="14161C"/>
+                </a:solidFill>
+                <a:latin typeface="Be Vietnam Pro" pitchFamily="34" charset="0"/>
+                <a:ea typeface="Be Vietnam Pro" pitchFamily="34" charset="-122"/>
+                <a:cs typeface="Be Vietnam Pro" pitchFamily="34" charset="-120"/>
+              </a:rPr>
+              <a:t> dừng</a:t>
             </a:r>
             <a:r>
               <a:rPr lang="en-US" sz="2250" dirty="0" spc="2" kern="0">
@@ -9730,62 +9972,7 @@
                 <a:ea typeface="Be Vietnam Pro" pitchFamily="34" charset="-122"/>
                 <a:cs typeface="Be Vietnam Pro" pitchFamily="34" charset="-120"/>
               </a:rPr>
-              <a:t> nhớ</a:t>
-            </a:r>
-            <a:r>
-              <a:rPr lang="en-US" sz="2250" dirty="0" spc="1" kern="0">
-                <a:solidFill>
-                  <a:srgbClr val="14161C"/>
-                </a:solidFill>
-                <a:latin typeface="Be Vietnam Pro" pitchFamily="34" charset="0"/>
-                <a:ea typeface="Be Vietnam Pro" pitchFamily="34" charset="-122"/>
-                <a:cs typeface="Be Vietnam Pro" pitchFamily="34" charset="-120"/>
-              </a:rPr>
-              <a:t> lớn, thời</a:t>
-            </a:r>
-            <a:r>
-              <a:rPr lang="en-US" sz="2250" dirty="0" spc="-2" kern="0">
-                <a:solidFill>
-                  <a:srgbClr val="14161C"/>
-                </a:solidFill>
-                <a:latin typeface="Be Vietnam Pro" pitchFamily="34" charset="0"/>
-                <a:ea typeface="Be Vietnam Pro" pitchFamily="34" charset="-122"/>
-                <a:cs typeface="Be Vietnam Pro" pitchFamily="34" charset="-120"/>
-              </a:rPr>
-              <a:t> gian</a:t>
-            </a:r>
-            <a:r>
-              <a:rPr lang="en-US" sz="2250" dirty="0" spc="21" kern="0">
-                <a:solidFill>
-                  <a:srgbClr val="14161C"/>
-                </a:solidFill>
-                <a:latin typeface="Be Vietnam Pro" pitchFamily="34" charset="0"/>
-                <a:ea typeface="Be Vietnam Pro" pitchFamily="34" charset="-122"/>
-                <a:cs typeface="Be Vietnam Pro" pitchFamily="34" charset="-120"/>
-              </a:rPr>
-              <a:t> dừng</a:t>
-            </a:r>
-            <a:r>
-              <a:rPr lang="en-US" sz="2250" dirty="0" spc="-11" kern="0">
-                <a:solidFill>
-                  <a:srgbClr val="14161C"/>
-                </a:solidFill>
-                <a:latin typeface="Be Vietnam Pro" pitchFamily="34" charset="0"/>
-                <a:ea typeface="Be Vietnam Pro" pitchFamily="34" charset="-122"/>
-                <a:cs typeface="Be Vietnam Pro" pitchFamily="34" charset="-120"/>
-              </a:rPr>
-              <a:t> tối</a:t>
-            </a:r>
-            <a:r>
-              <a:rPr lang="en-US" sz="2250" dirty="0" spc="0" kern="0">
-                <a:solidFill>
-                  <a:srgbClr val="14161C"/>
-                </a:solidFill>
-                <a:latin typeface="Be Vietnam Pro" pitchFamily="34" charset="0"/>
-                <a:ea typeface="Be Vietnam Pro" pitchFamily="34" charset="-122"/>
-                <a:cs typeface="Be Vietnam Pro" pitchFamily="34" charset="-120"/>
-              </a:rPr>
-              <a:t> thiểu.</a:t>
+              <a:t> thấp.</a:t>
             </a:r>
             <a:endParaRPr lang="en-US" sz="2250" dirty="0"/>
           </a:p>
@@ -9893,7 +10080,7 @@
               <a:t> từ</a:t>
             </a:r>
             <a:r>
-              <a:rPr lang="en-US" sz="1800" dirty="0" spc="-2" kern="0">
+              <a:rPr lang="en-US" sz="1800" dirty="0" spc="-9" kern="0">
                 <a:solidFill>
                   <a:srgbClr val="6B6A66"/>
                 </a:solidFill>
@@ -9901,7 +10088,7 @@
                 <a:ea typeface="Be Vietnam Pro" pitchFamily="34" charset="-122"/>
                 <a:cs typeface="Be Vietnam Pro" pitchFamily="34" charset="-120"/>
               </a:rPr>
-              <a:t> bài</a:t>
+              <a:t> tài</a:t>
             </a:r>
             <a:r>
               <a:rPr lang="en-US" sz="1800" dirty="0" spc="-3" kern="0">
@@ -9912,7 +10099,18 @@
                 <a:ea typeface="Be Vietnam Pro" pitchFamily="34" charset="-122"/>
                 <a:cs typeface="Be Vietnam Pro" pitchFamily="34" charset="-120"/>
               </a:rPr>
-              <a:t> nguồn.</a:t>
+              <a:t> liệu</a:t>
+            </a:r>
+            <a:r>
+              <a:rPr lang="en-US" sz="1800" dirty="0" spc="0" kern="0">
+                <a:solidFill>
+                  <a:srgbClr val="6B6A66"/>
+                </a:solidFill>
+                <a:latin typeface="Be Vietnam Pro" pitchFamily="34" charset="0"/>
+                <a:ea typeface="Be Vietnam Pro" pitchFamily="34" charset="-122"/>
+                <a:cs typeface="Be Vietnam Pro" pitchFamily="34" charset="-120"/>
+              </a:rPr>
+              <a:t> JDK.</a:t>
             </a:r>
             <a:endParaRPr lang="en-US" sz="1800" dirty="0"/>
           </a:p>

</xml_diff>